<commit_message>
Update: loyiha ishi - pastel/ochiq rang dizayn (ko'k, lavanda, krем tonlar)
</commit_message>
<xml_diff>
--- a/loyiha_ishi.pptx
+++ b/loyiha_ishi.pptx
@@ -129,7 +129,7 @@
             <a:avLst/>
           </a:prstGeom>
           <a:solidFill>
-            <a:srgbClr val="FFFFFF"/>
+            <a:srgbClr val="F8F9FF"/>
           </a:solidFill>
           <a:ln>
             <a:noFill/>
@@ -150,13 +150,13 @@
         <p:spPr>
           <a:xfrm>
             <a:off x="0" y="0"/>
-            <a:ext cx="12193200" cy="355600"/>
-          </a:xfrm>
-          <a:prstGeom prst="rect">
-            <a:avLst/>
-          </a:prstGeom>
-          <a:solidFill>
-            <a:srgbClr val="B8860B"/>
+            <a:ext cx="12193200" cy="406400"/>
+          </a:xfrm>
+          <a:prstGeom prst="rect">
+            <a:avLst/>
+          </a:prstGeom>
+          <a:solidFill>
+            <a:srgbClr val="D97706"/>
           </a:solidFill>
           <a:ln>
             <a:noFill/>
@@ -176,14 +176,14 @@
         </p:nvSpPr>
         <p:spPr>
           <a:xfrm>
-            <a:off x="0" y="6502400"/>
-            <a:ext cx="12193200" cy="355600"/>
-          </a:xfrm>
-          <a:prstGeom prst="rect">
-            <a:avLst/>
-          </a:prstGeom>
-          <a:solidFill>
-            <a:srgbClr val="B8860B"/>
+            <a:off x="0" y="6451600"/>
+            <a:ext cx="12193200" cy="406400"/>
+          </a:xfrm>
+          <a:prstGeom prst="rect">
+            <a:avLst/>
+          </a:prstGeom>
+          <a:solidFill>
+            <a:srgbClr val="D97706"/>
           </a:solidFill>
           <a:ln>
             <a:noFill/>
@@ -203,14 +203,14 @@
         </p:nvSpPr>
         <p:spPr>
           <a:xfrm>
-            <a:off x="0" y="355600"/>
-            <a:ext cx="127000" cy="6146800"/>
-          </a:xfrm>
-          <a:prstGeom prst="rect">
-            <a:avLst/>
-          </a:prstGeom>
-          <a:solidFill>
-            <a:srgbClr val="B8860B"/>
+            <a:off x="0" y="406400"/>
+            <a:ext cx="152400" cy="6045200"/>
+          </a:xfrm>
+          <a:prstGeom prst="rect">
+            <a:avLst/>
+          </a:prstGeom>
+          <a:solidFill>
+            <a:srgbClr val="D97706"/>
           </a:solidFill>
           <a:ln>
             <a:noFill/>
@@ -237,7 +237,7 @@
             <a:avLst/>
           </a:prstGeom>
           <a:solidFill>
-            <a:srgbClr val="B8860B"/>
+            <a:srgbClr val="D97706"/>
           </a:solidFill>
           <a:ln>
             <a:noFill/>
@@ -266,7 +266,7 @@
             </a:avLst>
           </a:prstGeom>
           <a:solidFill>
-            <a:srgbClr val="F0F4FF"/>
+            <a:srgbClr val="E0E7FF"/>
           </a:solidFill>
           <a:ln>
             <a:noFill/>
@@ -293,7 +293,7 @@
             <a:avLst/>
           </a:prstGeom>
           <a:solidFill>
-            <a:srgbClr val="B8860B"/>
+            <a:srgbClr val="D97706"/>
           </a:solidFill>
           <a:ln>
             <a:noFill/>
@@ -322,7 +322,7 @@
             </a:avLst>
           </a:prstGeom>
           <a:solidFill>
-            <a:srgbClr val="1D4ED8"/>
+            <a:srgbClr val="2563EB"/>
           </a:solidFill>
           <a:ln>
             <a:noFill/>
@@ -442,7 +442,7 @@
             <a:r>
               <a:rPr lang="uz-UZ" sz="2000" b="0" i="0" dirty="0">
                 <a:solidFill>
-                  <a:srgbClr val="B8860B"/>
+                  <a:srgbClr val="D97706"/>
                 </a:solidFill>
               </a:rPr>
               <a:t>Loyiha Ishi  —  D Maqsad  (13 ball)</a:t>
@@ -467,7 +467,7 @@
             </a:avLst>
           </a:prstGeom>
           <a:solidFill>
-            <a:srgbClr val="F0F4FF"/>
+            <a:srgbClr val="E0E7FF"/>
           </a:solidFill>
           <a:ln>
             <a:noFill/>
@@ -494,7 +494,7 @@
             <a:avLst/>
           </a:prstGeom>
           <a:solidFill>
-            <a:srgbClr val="B8860B"/>
+            <a:srgbClr val="D97706"/>
           </a:solidFill>
           <a:ln>
             <a:noFill/>
@@ -533,7 +533,7 @@
             <a:r>
               <a:rPr lang="uz-UZ" sz="1500" b="1" i="0" dirty="0">
                 <a:solidFill>
-                  <a:srgbClr val="B8860B"/>
+                  <a:srgbClr val="D97706"/>
                 </a:solidFill>
               </a:rPr>
               <a:t>Topshiriq</a:t>
@@ -593,7 +593,7 @@
             </a:avLst>
           </a:prstGeom>
           <a:solidFill>
-            <a:srgbClr val="F0F4FF"/>
+            <a:srgbClr val="E0E7FF"/>
           </a:solidFill>
           <a:ln>
             <a:noFill/>
@@ -620,7 +620,7 @@
             <a:avLst/>
           </a:prstGeom>
           <a:solidFill>
-            <a:srgbClr val="B8860B"/>
+            <a:srgbClr val="D97706"/>
           </a:solidFill>
           <a:ln>
             <a:noFill/>
@@ -659,7 +659,7 @@
             <a:r>
               <a:rPr lang="uz-UZ" sz="1500" b="1" i="0" dirty="0">
                 <a:solidFill>
-                  <a:srgbClr val="B8860B"/>
+                  <a:srgbClr val="D97706"/>
                 </a:solidFill>
               </a:rPr>
               <a:t>Modul</a:t>
@@ -719,7 +719,7 @@
             </a:avLst>
           </a:prstGeom>
           <a:solidFill>
-            <a:srgbClr val="F0F4FF"/>
+            <a:srgbClr val="E0E7FF"/>
           </a:solidFill>
           <a:ln>
             <a:noFill/>
@@ -746,7 +746,7 @@
             <a:avLst/>
           </a:prstGeom>
           <a:solidFill>
-            <a:srgbClr val="B8860B"/>
+            <a:srgbClr val="D97706"/>
           </a:solidFill>
           <a:ln>
             <a:noFill/>
@@ -785,7 +785,7 @@
             <a:r>
               <a:rPr lang="uz-UZ" sz="1500" b="1" i="0" dirty="0">
                 <a:solidFill>
-                  <a:srgbClr val="B8860B"/>
+                  <a:srgbClr val="D97706"/>
                 </a:solidFill>
               </a:rPr>
               <a:t>Dastur nomi</a:t>
@@ -845,7 +845,7 @@
             </a:avLst>
           </a:prstGeom>
           <a:solidFill>
-            <a:srgbClr val="F0F4FF"/>
+            <a:srgbClr val="E0E7FF"/>
           </a:solidFill>
           <a:ln>
             <a:noFill/>
@@ -872,7 +872,7 @@
             <a:avLst/>
           </a:prstGeom>
           <a:solidFill>
-            <a:srgbClr val="B8860B"/>
+            <a:srgbClr val="D97706"/>
           </a:solidFill>
           <a:ln>
             <a:noFill/>
@@ -911,7 +911,7 @@
             <a:r>
               <a:rPr lang="uz-UZ" sz="1500" b="1" i="0" dirty="0">
                 <a:solidFill>
-                  <a:srgbClr val="B8860B"/>
+                  <a:srgbClr val="D97706"/>
                 </a:solidFill>
               </a:rPr>
               <a:t>Muddati</a:t>
@@ -1029,7 +1029,7 @@
             <a:avLst/>
           </a:prstGeom>
           <a:solidFill>
-            <a:srgbClr val="FFFFFF"/>
+            <a:srgbClr val="F8F9FF"/>
           </a:solidFill>
           <a:ln>
             <a:noFill/>
@@ -1050,7 +1050,7 @@
         <p:spPr>
           <a:xfrm>
             <a:off x="0" y="0"/>
-            <a:ext cx="12193200" cy="355600"/>
+            <a:ext cx="12193200" cy="406400"/>
           </a:xfrm>
           <a:prstGeom prst="rect">
             <a:avLst/>
@@ -1076,8 +1076,8 @@
         </p:nvSpPr>
         <p:spPr>
           <a:xfrm>
-            <a:off x="0" y="6502400"/>
-            <a:ext cx="12193200" cy="355600"/>
+            <a:off x="0" y="6451600"/>
+            <a:ext cx="12193200" cy="406400"/>
           </a:xfrm>
           <a:prstGeom prst="rect">
             <a:avLst/>
@@ -1103,8 +1103,8 @@
         </p:nvSpPr>
         <p:spPr>
           <a:xfrm>
-            <a:off x="0" y="355600"/>
-            <a:ext cx="127000" cy="6146800"/>
+            <a:off x="0" y="406400"/>
+            <a:ext cx="152400" cy="6045200"/>
           </a:xfrm>
           <a:prstGeom prst="rect">
             <a:avLst/>
@@ -1176,7 +1176,7 @@
             <a:r>
               <a:rPr lang="uz-UZ" sz="2800" b="1" i="0" dirty="0">
                 <a:solidFill>
-                  <a:srgbClr val="111827"/>
+                  <a:srgbClr val="1E1B4B"/>
                 </a:solidFill>
               </a:rPr>
               <a:t>DP 9  |  MUAMMO HAL ETISH — 5 BOSQICH METODI</a:t>
@@ -1238,7 +1238,7 @@
             <a:r>
               <a:rPr lang="uz-UZ" sz="1800" b="0" i="0" dirty="0">
                 <a:solidFill>
-                  <a:srgbClr val="B8860B"/>
+                  <a:srgbClr val="D97706"/>
                 </a:solidFill>
               </a:rPr>
               <a:t>Holat: Tarmoq skanerlash 150 ta qurilmadan 3-5 tasini o'tkazib yuborardi</a:t>
@@ -1263,7 +1263,7 @@
             </a:avLst>
           </a:prstGeom>
           <a:solidFill>
-            <a:srgbClr val="F0F4FF"/>
+            <a:srgbClr val="E0E7FF"/>
           </a:solidFill>
           <a:ln>
             <a:noFill/>
@@ -1428,7 +1428,7 @@
             <a:r>
               <a:rPr lang="uz-UZ" sz="1700" b="0" i="0" dirty="0">
                 <a:solidFill>
-                  <a:srgbClr val="1F2937"/>
+                  <a:srgbClr val="374151"/>
                 </a:solidFill>
               </a:rPr>
               <a:t>Log fayllar tahlili → qaysi IP manzillar o'tkazib yuborilmoqda?</a:t>
@@ -1453,7 +1453,7 @@
             </a:avLst>
           </a:prstGeom>
           <a:solidFill>
-            <a:srgbClr val="F0F4FF"/>
+            <a:srgbClr val="E0E7FF"/>
           </a:solidFill>
           <a:ln>
             <a:noFill/>
@@ -1480,7 +1480,7 @@
             <a:avLst/>
           </a:prstGeom>
           <a:solidFill>
-            <a:srgbClr val="B8860B"/>
+            <a:srgbClr val="D97706"/>
           </a:solidFill>
           <a:ln>
             <a:noFill/>
@@ -1509,7 +1509,7 @@
             </a:avLst>
           </a:prstGeom>
           <a:solidFill>
-            <a:srgbClr val="B8860B"/>
+            <a:srgbClr val="D97706"/>
           </a:solidFill>
           <a:ln>
             <a:noFill/>
@@ -1583,7 +1583,7 @@
             <a:r>
               <a:rPr lang="uz-UZ" sz="1900" b="1" i="0" dirty="0">
                 <a:solidFill>
-                  <a:srgbClr val="B8860B"/>
+                  <a:srgbClr val="D97706"/>
                 </a:solidFill>
               </a:rPr>
               <a:t>2  SABAB</a:t>
@@ -1618,7 +1618,7 @@
             <a:r>
               <a:rPr lang="uz-UZ" sz="1700" b="0" i="0" dirty="0">
                 <a:solidFill>
-                  <a:srgbClr val="1F2937"/>
+                  <a:srgbClr val="374151"/>
                 </a:solidFill>
               </a:rPr>
               <a:t>Timeout = 0.5 sek (juda qisqa). Ba'zi qurilmalar sekin javob qaytaradi.</a:t>
@@ -1643,7 +1643,7 @@
             </a:avLst>
           </a:prstGeom>
           <a:solidFill>
-            <a:srgbClr val="F0F4FF"/>
+            <a:srgbClr val="E0E7FF"/>
           </a:solidFill>
           <a:ln>
             <a:noFill/>
@@ -1670,7 +1670,7 @@
             <a:avLst/>
           </a:prstGeom>
           <a:solidFill>
-            <a:srgbClr val="1D4ED8"/>
+            <a:srgbClr val="2563EB"/>
           </a:solidFill>
           <a:ln>
             <a:noFill/>
@@ -1699,7 +1699,7 @@
             </a:avLst>
           </a:prstGeom>
           <a:solidFill>
-            <a:srgbClr val="1D4ED8"/>
+            <a:srgbClr val="2563EB"/>
           </a:solidFill>
           <a:ln>
             <a:noFill/>
@@ -1773,7 +1773,7 @@
             <a:r>
               <a:rPr lang="uz-UZ" sz="1900" b="1" i="0" dirty="0">
                 <a:solidFill>
-                  <a:srgbClr val="1D4ED8"/>
+                  <a:srgbClr val="2563EB"/>
                 </a:solidFill>
               </a:rPr>
               <a:t>3  YECHIM</a:t>
@@ -1808,7 +1808,7 @@
             <a:r>
               <a:rPr lang="uz-UZ" sz="1700" b="0" i="0" dirty="0">
                 <a:solidFill>
-                  <a:srgbClr val="1F2937"/>
+                  <a:srgbClr val="374151"/>
                 </a:solidFill>
               </a:rPr>
               <a:t>Adaptive timeout algoritmi: qurilma turi va kechikishiga qarab avto-moslash</a:t>
@@ -1833,7 +1833,7 @@
             </a:avLst>
           </a:prstGeom>
           <a:solidFill>
-            <a:srgbClr val="F0F4FF"/>
+            <a:srgbClr val="E0E7FF"/>
           </a:solidFill>
           <a:ln>
             <a:noFill/>
@@ -1998,7 +1998,7 @@
             <a:r>
               <a:rPr lang="uz-UZ" sz="1700" b="0" i="0" dirty="0">
                 <a:solidFill>
-                  <a:srgbClr val="1F2937"/>
+                  <a:srgbClr val="374151"/>
                 </a:solidFill>
               </a:rPr>
               <a:t>3 marta to'liq skanerlash: 150/150 qurilma aniqlandi → 100% aniqlik</a:t>
@@ -2023,7 +2023,7 @@
             </a:avLst>
           </a:prstGeom>
           <a:solidFill>
-            <a:srgbClr val="F0F4FF"/>
+            <a:srgbClr val="E0E7FF"/>
           </a:solidFill>
           <a:ln>
             <a:noFill/>
@@ -2050,7 +2050,7 @@
             <a:avLst/>
           </a:prstGeom>
           <a:solidFill>
-            <a:srgbClr val="DC2626"/>
+            <a:srgbClr val="E11D48"/>
           </a:solidFill>
           <a:ln>
             <a:noFill/>
@@ -2079,7 +2079,7 @@
             </a:avLst>
           </a:prstGeom>
           <a:solidFill>
-            <a:srgbClr val="DC2626"/>
+            <a:srgbClr val="E11D48"/>
           </a:solidFill>
           <a:ln>
             <a:noFill/>
@@ -2153,7 +2153,7 @@
             <a:r>
               <a:rPr lang="uz-UZ" sz="1900" b="1" i="0" dirty="0">
                 <a:solidFill>
-                  <a:srgbClr val="DC2626"/>
+                  <a:srgbClr val="E11D48"/>
                 </a:solidFill>
               </a:rPr>
               <a:t>5  HUJJATLASHTIRISH</a:t>
@@ -2188,7 +2188,7 @@
             <a:r>
               <a:rPr lang="uz-UZ" sz="1700" b="0" i="0" dirty="0">
                 <a:solidFill>
-                  <a:srgbClr val="1F2937"/>
+                  <a:srgbClr val="374151"/>
                 </a:solidFill>
               </a:rPr>
               <a:t>Muammo + yechim + saboq texnik hujjatga yozildi → kelajak loyihalar uchun</a:t>
@@ -2271,7 +2271,7 @@
             <a:avLst/>
           </a:prstGeom>
           <a:solidFill>
-            <a:srgbClr val="FFFFFF"/>
+            <a:srgbClr val="F8F9FF"/>
           </a:solidFill>
           <a:ln>
             <a:noFill/>
@@ -2292,13 +2292,13 @@
         <p:spPr>
           <a:xfrm>
             <a:off x="0" y="0"/>
-            <a:ext cx="12193200" cy="355600"/>
-          </a:xfrm>
-          <a:prstGeom prst="rect">
-            <a:avLst/>
-          </a:prstGeom>
-          <a:solidFill>
-            <a:srgbClr val="B8860B"/>
+            <a:ext cx="12193200" cy="406400"/>
+          </a:xfrm>
+          <a:prstGeom prst="rect">
+            <a:avLst/>
+          </a:prstGeom>
+          <a:solidFill>
+            <a:srgbClr val="D97706"/>
           </a:solidFill>
           <a:ln>
             <a:noFill/>
@@ -2318,14 +2318,14 @@
         </p:nvSpPr>
         <p:spPr>
           <a:xfrm>
-            <a:off x="0" y="6502400"/>
-            <a:ext cx="12193200" cy="355600"/>
-          </a:xfrm>
-          <a:prstGeom prst="rect">
-            <a:avLst/>
-          </a:prstGeom>
-          <a:solidFill>
-            <a:srgbClr val="B8860B"/>
+            <a:off x="0" y="6451600"/>
+            <a:ext cx="12193200" cy="406400"/>
+          </a:xfrm>
+          <a:prstGeom prst="rect">
+            <a:avLst/>
+          </a:prstGeom>
+          <a:solidFill>
+            <a:srgbClr val="D97706"/>
           </a:solidFill>
           <a:ln>
             <a:noFill/>
@@ -2345,14 +2345,14 @@
         </p:nvSpPr>
         <p:spPr>
           <a:xfrm>
-            <a:off x="0" y="355600"/>
-            <a:ext cx="127000" cy="6146800"/>
-          </a:xfrm>
-          <a:prstGeom prst="rect">
-            <a:avLst/>
-          </a:prstGeom>
-          <a:solidFill>
-            <a:srgbClr val="B8860B"/>
+            <a:off x="0" y="406400"/>
+            <a:ext cx="152400" cy="6045200"/>
+          </a:xfrm>
+          <a:prstGeom prst="rect">
+            <a:avLst/>
+          </a:prstGeom>
+          <a:solidFill>
+            <a:srgbClr val="D97706"/>
           </a:solidFill>
           <a:ln>
             <a:noFill/>
@@ -2379,7 +2379,7 @@
             <a:avLst/>
           </a:prstGeom>
           <a:solidFill>
-            <a:srgbClr val="B8860B"/>
+            <a:srgbClr val="D97706"/>
           </a:solidFill>
           <a:ln>
             <a:noFill/>
@@ -2418,7 +2418,7 @@
             <a:r>
               <a:rPr lang="uz-UZ" sz="2800" b="1" i="0" dirty="0">
                 <a:solidFill>
-                  <a:srgbClr val="111827"/>
+                  <a:srgbClr val="1E1B4B"/>
                 </a:solidFill>
               </a:rPr>
               <a:t>LOYIHA NATIJALARI — KPI JADVAL</a:t>
@@ -2441,7 +2441,7 @@
             <a:avLst/>
           </a:prstGeom>
           <a:solidFill>
-            <a:srgbClr val="B8860B"/>
+            <a:srgbClr val="D97706"/>
           </a:solidFill>
           <a:ln>
             <a:noFill/>
@@ -2468,7 +2468,7 @@
             <a:avLst/>
           </a:prstGeom>
           <a:solidFill>
-            <a:srgbClr val="1D4ED8"/>
+            <a:srgbClr val="2563EB"/>
           </a:solidFill>
           <a:ln>
             <a:noFill/>
@@ -2530,7 +2530,7 @@
             <a:avLst/>
           </a:prstGeom>
           <a:solidFill>
-            <a:srgbClr val="1D4ED8"/>
+            <a:srgbClr val="2563EB"/>
           </a:solidFill>
           <a:ln>
             <a:noFill/>
@@ -2592,7 +2592,7 @@
             <a:avLst/>
           </a:prstGeom>
           <a:solidFill>
-            <a:srgbClr val="1D4ED8"/>
+            <a:srgbClr val="2563EB"/>
           </a:solidFill>
           <a:ln>
             <a:noFill/>
@@ -2654,7 +2654,7 @@
             <a:avLst/>
           </a:prstGeom>
           <a:solidFill>
-            <a:srgbClr val="1D4ED8"/>
+            <a:srgbClr val="2563EB"/>
           </a:solidFill>
           <a:ln>
             <a:noFill/>
@@ -2718,7 +2718,7 @@
             </a:avLst>
           </a:prstGeom>
           <a:solidFill>
-            <a:srgbClr val="F0F4FF"/>
+            <a:srgbClr val="E0E7FF"/>
           </a:solidFill>
           <a:ln>
             <a:noFill/>
@@ -2757,7 +2757,7 @@
             <a:r>
               <a:rPr lang="uz-UZ" sz="1700" b="1" i="0" dirty="0">
                 <a:solidFill>
-                  <a:srgbClr val="B8860B"/>
+                  <a:srgbClr val="D97706"/>
                 </a:solidFill>
               </a:rPr>
               <a:t>Qurilma aniqlash aniqligi</a:t>
@@ -2782,7 +2782,7 @@
             </a:avLst>
           </a:prstGeom>
           <a:solidFill>
-            <a:srgbClr val="F0F4FF"/>
+            <a:srgbClr val="E0E7FF"/>
           </a:solidFill>
           <a:ln>
             <a:noFill/>
@@ -2821,7 +2821,7 @@
             <a:r>
               <a:rPr lang="uz-UZ" sz="1700" b="0" i="0" dirty="0">
                 <a:solidFill>
-                  <a:srgbClr val="1F2937"/>
+                  <a:srgbClr val="374151"/>
                 </a:solidFill>
               </a:rPr>
               <a:t>95%</a:t>
@@ -2846,7 +2846,7 @@
             </a:avLst>
           </a:prstGeom>
           <a:solidFill>
-            <a:srgbClr val="F0F4FF"/>
+            <a:srgbClr val="E0E7FF"/>
           </a:solidFill>
           <a:ln>
             <a:noFill/>
@@ -2885,7 +2885,7 @@
             <a:r>
               <a:rPr lang="uz-UZ" sz="1700" b="0" i="0" dirty="0">
                 <a:solidFill>
-                  <a:srgbClr val="1F2937"/>
+                  <a:srgbClr val="374151"/>
                 </a:solidFill>
               </a:rPr>
               <a:t>100%</a:t>
@@ -2910,7 +2910,7 @@
             </a:avLst>
           </a:prstGeom>
           <a:solidFill>
-            <a:srgbClr val="F0F4FF"/>
+            <a:srgbClr val="E0E7FF"/>
           </a:solidFill>
           <a:ln>
             <a:noFill/>
@@ -2949,7 +2949,7 @@
             <a:r>
               <a:rPr lang="uz-UZ" sz="1700" b="1" i="0" dirty="0">
                 <a:solidFill>
-                  <a:srgbClr val="15803D"/>
+                  <a:srgbClr val="059669"/>
                 </a:solidFill>
               </a:rPr>
               <a:t>✅ Oshirib bajarildi</a:t>
@@ -2974,7 +2974,7 @@
             </a:avLst>
           </a:prstGeom>
           <a:solidFill>
-            <a:srgbClr val="FFF8E1"/>
+            <a:srgbClr val="FEF9EC"/>
           </a:solidFill>
           <a:ln>
             <a:noFill/>
@@ -3013,7 +3013,7 @@
             <a:r>
               <a:rPr lang="uz-UZ" sz="1700" b="1" i="0" dirty="0">
                 <a:solidFill>
-                  <a:srgbClr val="B8860B"/>
+                  <a:srgbClr val="D97706"/>
                 </a:solidFill>
               </a:rPr>
               <a:t>Skanerlash vaqti (150 ta)</a:t>
@@ -3038,7 +3038,7 @@
             </a:avLst>
           </a:prstGeom>
           <a:solidFill>
-            <a:srgbClr val="FFF8E1"/>
+            <a:srgbClr val="FEF9EC"/>
           </a:solidFill>
           <a:ln>
             <a:noFill/>
@@ -3077,7 +3077,7 @@
             <a:r>
               <a:rPr lang="uz-UZ" sz="1700" b="0" i="0" dirty="0">
                 <a:solidFill>
-                  <a:srgbClr val="1F2937"/>
+                  <a:srgbClr val="374151"/>
                 </a:solidFill>
               </a:rPr>
               <a:t>2 daqiqa</a:t>
@@ -3102,7 +3102,7 @@
             </a:avLst>
           </a:prstGeom>
           <a:solidFill>
-            <a:srgbClr val="FFF8E1"/>
+            <a:srgbClr val="FEF9EC"/>
           </a:solidFill>
           <a:ln>
             <a:noFill/>
@@ -3141,7 +3141,7 @@
             <a:r>
               <a:rPr lang="uz-UZ" sz="1700" b="0" i="0" dirty="0">
                 <a:solidFill>
-                  <a:srgbClr val="1F2937"/>
+                  <a:srgbClr val="374151"/>
                 </a:solidFill>
               </a:rPr>
               <a:t>45 soniya</a:t>
@@ -3166,7 +3166,7 @@
             </a:avLst>
           </a:prstGeom>
           <a:solidFill>
-            <a:srgbClr val="FFF8E1"/>
+            <a:srgbClr val="FEF9EC"/>
           </a:solidFill>
           <a:ln>
             <a:noFill/>
@@ -3205,7 +3205,7 @@
             <a:r>
               <a:rPr lang="uz-UZ" sz="1700" b="1" i="0" dirty="0">
                 <a:solidFill>
-                  <a:srgbClr val="15803D"/>
+                  <a:srgbClr val="059669"/>
                 </a:solidFill>
               </a:rPr>
               <a:t>✅ Oshirib bajarildi</a:t>
@@ -3230,7 +3230,7 @@
             </a:avLst>
           </a:prstGeom>
           <a:solidFill>
-            <a:srgbClr val="F0F4FF"/>
+            <a:srgbClr val="E0E7FF"/>
           </a:solidFill>
           <a:ln>
             <a:noFill/>
@@ -3269,7 +3269,7 @@
             <a:r>
               <a:rPr lang="uz-UZ" sz="1700" b="1" i="0" dirty="0">
                 <a:solidFill>
-                  <a:srgbClr val="B8860B"/>
+                  <a:srgbClr val="D97706"/>
                 </a:solidFill>
               </a:rPr>
               <a:t>Tizim ishlamay qolishi</a:t>
@@ -3294,7 +3294,7 @@
             </a:avLst>
           </a:prstGeom>
           <a:solidFill>
-            <a:srgbClr val="F0F4FF"/>
+            <a:srgbClr val="E0E7FF"/>
           </a:solidFill>
           <a:ln>
             <a:noFill/>
@@ -3333,7 +3333,7 @@
             <a:r>
               <a:rPr lang="uz-UZ" sz="1700" b="0" i="0" dirty="0">
                 <a:solidFill>
-                  <a:srgbClr val="1F2937"/>
+                  <a:srgbClr val="374151"/>
                 </a:solidFill>
               </a:rPr>
               <a:t>&lt; 1 soat/oy</a:t>
@@ -3358,7 +3358,7 @@
             </a:avLst>
           </a:prstGeom>
           <a:solidFill>
-            <a:srgbClr val="F0F4FF"/>
+            <a:srgbClr val="E0E7FF"/>
           </a:solidFill>
           <a:ln>
             <a:noFill/>
@@ -3397,7 +3397,7 @@
             <a:r>
               <a:rPr lang="uz-UZ" sz="1700" b="0" i="0" dirty="0">
                 <a:solidFill>
-                  <a:srgbClr val="1F2937"/>
+                  <a:srgbClr val="374151"/>
                 </a:solidFill>
               </a:rPr>
               <a:t>0 daqiqa</a:t>
@@ -3422,7 +3422,7 @@
             </a:avLst>
           </a:prstGeom>
           <a:solidFill>
-            <a:srgbClr val="F0F4FF"/>
+            <a:srgbClr val="E0E7FF"/>
           </a:solidFill>
           <a:ln>
             <a:noFill/>
@@ -3461,7 +3461,7 @@
             <a:r>
               <a:rPr lang="uz-UZ" sz="1700" b="1" i="0" dirty="0">
                 <a:solidFill>
-                  <a:srgbClr val="15803D"/>
+                  <a:srgbClr val="059669"/>
                 </a:solidFill>
               </a:rPr>
               <a:t>✅ Bajarildi</a:t>
@@ -3486,7 +3486,7 @@
             </a:avLst>
           </a:prstGeom>
           <a:solidFill>
-            <a:srgbClr val="FFF8E1"/>
+            <a:srgbClr val="FEF9EC"/>
           </a:solidFill>
           <a:ln>
             <a:noFill/>
@@ -3525,7 +3525,7 @@
             <a:r>
               <a:rPr lang="uz-UZ" sz="1700" b="1" i="0" dirty="0">
                 <a:solidFill>
-                  <a:srgbClr val="B8860B"/>
+                  <a:srgbClr val="D97706"/>
                 </a:solidFill>
               </a:rPr>
               <a:t>Hisobot tayyorlash vaqti</a:t>
@@ -3550,7 +3550,7 @@
             </a:avLst>
           </a:prstGeom>
           <a:solidFill>
-            <a:srgbClr val="FFF8E1"/>
+            <a:srgbClr val="FEF9EC"/>
           </a:solidFill>
           <a:ln>
             <a:noFill/>
@@ -3589,7 +3589,7 @@
             <a:r>
               <a:rPr lang="uz-UZ" sz="1700" b="0" i="0" dirty="0">
                 <a:solidFill>
-                  <a:srgbClr val="1F2937"/>
+                  <a:srgbClr val="374151"/>
                 </a:solidFill>
               </a:rPr>
               <a:t>30 daqiqa</a:t>
@@ -3614,7 +3614,7 @@
             </a:avLst>
           </a:prstGeom>
           <a:solidFill>
-            <a:srgbClr val="FFF8E1"/>
+            <a:srgbClr val="FEF9EC"/>
           </a:solidFill>
           <a:ln>
             <a:noFill/>
@@ -3653,7 +3653,7 @@
             <a:r>
               <a:rPr lang="uz-UZ" sz="1700" b="0" i="0" dirty="0">
                 <a:solidFill>
-                  <a:srgbClr val="1F2937"/>
+                  <a:srgbClr val="374151"/>
                 </a:solidFill>
               </a:rPr>
               <a:t>2 daqiqa</a:t>
@@ -3678,7 +3678,7 @@
             </a:avLst>
           </a:prstGeom>
           <a:solidFill>
-            <a:srgbClr val="FFF8E1"/>
+            <a:srgbClr val="FEF9EC"/>
           </a:solidFill>
           <a:ln>
             <a:noFill/>
@@ -3717,7 +3717,7 @@
             <a:r>
               <a:rPr lang="uz-UZ" sz="1700" b="1" i="0" dirty="0">
                 <a:solidFill>
-                  <a:srgbClr val="15803D"/>
+                  <a:srgbClr val="059669"/>
                 </a:solidFill>
               </a:rPr>
               <a:t>✅ Avtomatlashtirildi</a:t>
@@ -3742,7 +3742,7 @@
             </a:avLst>
           </a:prstGeom>
           <a:solidFill>
-            <a:srgbClr val="F0F4FF"/>
+            <a:srgbClr val="E0E7FF"/>
           </a:solidFill>
           <a:ln>
             <a:noFill/>
@@ -3781,7 +3781,7 @@
             <a:r>
               <a:rPr lang="uz-UZ" sz="1700" b="1" i="0" dirty="0">
                 <a:solidFill>
-                  <a:srgbClr val="B8860B"/>
+                  <a:srgbClr val="D97706"/>
                 </a:solidFill>
               </a:rPr>
               <a:t>Xavfsizlik hodisalari</a:t>
@@ -3806,7 +3806,7 @@
             </a:avLst>
           </a:prstGeom>
           <a:solidFill>
-            <a:srgbClr val="F0F4FF"/>
+            <a:srgbClr val="E0E7FF"/>
           </a:solidFill>
           <a:ln>
             <a:noFill/>
@@ -3845,7 +3845,7 @@
             <a:r>
               <a:rPr lang="uz-UZ" sz="1700" b="0" i="0" dirty="0">
                 <a:solidFill>
-                  <a:srgbClr val="1F2937"/>
+                  <a:srgbClr val="374151"/>
                 </a:solidFill>
               </a:rPr>
               <a:t>0</a:t>
@@ -3870,7 +3870,7 @@
             </a:avLst>
           </a:prstGeom>
           <a:solidFill>
-            <a:srgbClr val="F0F4FF"/>
+            <a:srgbClr val="E0E7FF"/>
           </a:solidFill>
           <a:ln>
             <a:noFill/>
@@ -3909,7 +3909,7 @@
             <a:r>
               <a:rPr lang="uz-UZ" sz="1700" b="0" i="0" dirty="0">
                 <a:solidFill>
-                  <a:srgbClr val="1F2937"/>
+                  <a:srgbClr val="374151"/>
                 </a:solidFill>
               </a:rPr>
               <a:t>0</a:t>
@@ -3934,7 +3934,7 @@
             </a:avLst>
           </a:prstGeom>
           <a:solidFill>
-            <a:srgbClr val="F0F4FF"/>
+            <a:srgbClr val="E0E7FF"/>
           </a:solidFill>
           <a:ln>
             <a:noFill/>
@@ -3973,7 +3973,7 @@
             <a:r>
               <a:rPr lang="uz-UZ" sz="1700" b="1" i="0" dirty="0">
                 <a:solidFill>
-                  <a:srgbClr val="15803D"/>
+                  <a:srgbClr val="059669"/>
                 </a:solidFill>
               </a:rPr>
               <a:t>✅ Bajarildi</a:t>
@@ -3998,7 +3998,7 @@
             </a:avLst>
           </a:prstGeom>
           <a:solidFill>
-            <a:srgbClr val="FFF8E1"/>
+            <a:srgbClr val="FEF9EC"/>
           </a:solidFill>
           <a:ln>
             <a:noFill/>
@@ -4037,7 +4037,7 @@
             <a:r>
               <a:rPr lang="uz-UZ" sz="1700" b="1" i="0" dirty="0">
                 <a:solidFill>
-                  <a:srgbClr val="B8860B"/>
+                  <a:srgbClr val="D97706"/>
                 </a:solidFill>
               </a:rPr>
               <a:t>Loyiha muddati</a:t>
@@ -4062,7 +4062,7 @@
             </a:avLst>
           </a:prstGeom>
           <a:solidFill>
-            <a:srgbClr val="FFF8E1"/>
+            <a:srgbClr val="FEF9EC"/>
           </a:solidFill>
           <a:ln>
             <a:noFill/>
@@ -4101,7 +4101,7 @@
             <a:r>
               <a:rPr lang="uz-UZ" sz="1700" b="0" i="0" dirty="0">
                 <a:solidFill>
-                  <a:srgbClr val="1F2937"/>
+                  <a:srgbClr val="374151"/>
                 </a:solidFill>
               </a:rPr>
               <a:t>8 hafta</a:t>
@@ -4126,7 +4126,7 @@
             </a:avLst>
           </a:prstGeom>
           <a:solidFill>
-            <a:srgbClr val="FFF8E1"/>
+            <a:srgbClr val="FEF9EC"/>
           </a:solidFill>
           <a:ln>
             <a:noFill/>
@@ -4165,7 +4165,7 @@
             <a:r>
               <a:rPr lang="uz-UZ" sz="1700" b="0" i="0" dirty="0">
                 <a:solidFill>
-                  <a:srgbClr val="1F2937"/>
+                  <a:srgbClr val="374151"/>
                 </a:solidFill>
               </a:rPr>
               <a:t>7.5 hafta</a:t>
@@ -4190,7 +4190,7 @@
             </a:avLst>
           </a:prstGeom>
           <a:solidFill>
-            <a:srgbClr val="FFF8E1"/>
+            <a:srgbClr val="FEF9EC"/>
           </a:solidFill>
           <a:ln>
             <a:noFill/>
@@ -4229,7 +4229,7 @@
             <a:r>
               <a:rPr lang="uz-UZ" sz="1700" b="1" i="0" dirty="0">
                 <a:solidFill>
-                  <a:srgbClr val="15803D"/>
+                  <a:srgbClr val="059669"/>
                 </a:solidFill>
               </a:rPr>
               <a:t>✅ Muddatdan oldin</a:t>
@@ -4312,7 +4312,7 @@
             <a:avLst/>
           </a:prstGeom>
           <a:solidFill>
-            <a:srgbClr val="FFFFFF"/>
+            <a:srgbClr val="F8F9FF"/>
           </a:solidFill>
           <a:ln>
             <a:noFill/>
@@ -4333,13 +4333,13 @@
         <p:spPr>
           <a:xfrm>
             <a:off x="0" y="0"/>
-            <a:ext cx="12193200" cy="355600"/>
-          </a:xfrm>
-          <a:prstGeom prst="rect">
-            <a:avLst/>
-          </a:prstGeom>
-          <a:solidFill>
-            <a:srgbClr val="1D4ED8"/>
+            <a:ext cx="12193200" cy="406400"/>
+          </a:xfrm>
+          <a:prstGeom prst="rect">
+            <a:avLst/>
+          </a:prstGeom>
+          <a:solidFill>
+            <a:srgbClr val="2563EB"/>
           </a:solidFill>
           <a:ln>
             <a:noFill/>
@@ -4359,14 +4359,14 @@
         </p:nvSpPr>
         <p:spPr>
           <a:xfrm>
-            <a:off x="0" y="6502400"/>
-            <a:ext cx="12193200" cy="355600"/>
-          </a:xfrm>
-          <a:prstGeom prst="rect">
-            <a:avLst/>
-          </a:prstGeom>
-          <a:solidFill>
-            <a:srgbClr val="1D4ED8"/>
+            <a:off x="0" y="6451600"/>
+            <a:ext cx="12193200" cy="406400"/>
+          </a:xfrm>
+          <a:prstGeom prst="rect">
+            <a:avLst/>
+          </a:prstGeom>
+          <a:solidFill>
+            <a:srgbClr val="2563EB"/>
           </a:solidFill>
           <a:ln>
             <a:noFill/>
@@ -4386,14 +4386,14 @@
         </p:nvSpPr>
         <p:spPr>
           <a:xfrm>
-            <a:off x="0" y="355600"/>
-            <a:ext cx="127000" cy="6146800"/>
-          </a:xfrm>
-          <a:prstGeom prst="rect">
-            <a:avLst/>
-          </a:prstGeom>
-          <a:solidFill>
-            <a:srgbClr val="1D4ED8"/>
+            <a:off x="0" y="406400"/>
+            <a:ext cx="152400" cy="6045200"/>
+          </a:xfrm>
+          <a:prstGeom prst="rect">
+            <a:avLst/>
+          </a:prstGeom>
+          <a:solidFill>
+            <a:srgbClr val="2563EB"/>
           </a:solidFill>
           <a:ln>
             <a:noFill/>
@@ -4420,7 +4420,7 @@
             <a:avLst/>
           </a:prstGeom>
           <a:solidFill>
-            <a:srgbClr val="1D4ED8"/>
+            <a:srgbClr val="2563EB"/>
           </a:solidFill>
           <a:ln>
             <a:noFill/>
@@ -4459,7 +4459,7 @@
             <a:r>
               <a:rPr lang="uz-UZ" sz="2800" b="1" i="0" dirty="0">
                 <a:solidFill>
-                  <a:srgbClr val="111827"/>
+                  <a:srgbClr val="1E1B4B"/>
                 </a:solidFill>
               </a:rPr>
               <a:t>XULOSA VA SHAXSIY RIVOJLANISH</a:t>
@@ -4482,7 +4482,7 @@
             <a:avLst/>
           </a:prstGeom>
           <a:solidFill>
-            <a:srgbClr val="1D4ED8"/>
+            <a:srgbClr val="2563EB"/>
           </a:solidFill>
           <a:ln>
             <a:noFill/>
@@ -4511,7 +4511,7 @@
             </a:avLst>
           </a:prstGeom>
           <a:solidFill>
-            <a:srgbClr val="F0F4FF"/>
+            <a:srgbClr val="E0E7FF"/>
           </a:solidFill>
           <a:ln>
             <a:noFill/>
@@ -4538,7 +4538,7 @@
             <a:avLst/>
           </a:prstGeom>
           <a:solidFill>
-            <a:srgbClr val="B8860B"/>
+            <a:srgbClr val="D97706"/>
           </a:solidFill>
           <a:ln>
             <a:noFill/>
@@ -4577,7 +4577,7 @@
             <a:r>
               <a:rPr lang="uz-UZ" sz="2000" b="1" i="0" dirty="0">
                 <a:solidFill>
-                  <a:srgbClr val="B8860B"/>
+                  <a:srgbClr val="D97706"/>
                 </a:solidFill>
               </a:rPr>
               <a:t>Texnik Ko'nikmalar</a:t>
@@ -4612,7 +4612,7 @@
             <a:r>
               <a:rPr lang="uz-UZ" sz="1750" b="0" i="0" dirty="0">
                 <a:solidFill>
-                  <a:srgbClr val="1F2937"/>
+                  <a:srgbClr val="374151"/>
                 </a:solidFill>
               </a:rPr>
               <a:t>Python multithreading, Docker, REST API, Grafana — barchasi amaliyotda o'rganildi</a:t>
@@ -4637,7 +4637,7 @@
             </a:avLst>
           </a:prstGeom>
           <a:solidFill>
-            <a:srgbClr val="F0F4FF"/>
+            <a:srgbClr val="E0E7FF"/>
           </a:solidFill>
           <a:ln>
             <a:noFill/>
@@ -4664,7 +4664,7 @@
             <a:avLst/>
           </a:prstGeom>
           <a:solidFill>
-            <a:srgbClr val="1D4ED8"/>
+            <a:srgbClr val="2563EB"/>
           </a:solidFill>
           <a:ln>
             <a:noFill/>
@@ -4703,7 +4703,7 @@
             <a:r>
               <a:rPr lang="uz-UZ" sz="2000" b="1" i="0" dirty="0">
                 <a:solidFill>
-                  <a:srgbClr val="1D4ED8"/>
+                  <a:srgbClr val="2563EB"/>
                 </a:solidFill>
               </a:rPr>
               <a:t>Loyiha Boshqaruvi</a:t>
@@ -4738,7 +4738,7 @@
             <a:r>
               <a:rPr lang="uz-UZ" sz="1750" b="0" i="0" dirty="0">
                 <a:solidFill>
-                  <a:srgbClr val="1F2937"/>
+                  <a:srgbClr val="374151"/>
                 </a:solidFill>
               </a:rPr>
               <a:t>Agile/Scrum real loyihada qo'llandi; risk va muloqot boshqaruvi puxta o'zlashtirildi</a:t>
@@ -4763,7 +4763,7 @@
             </a:avLst>
           </a:prstGeom>
           <a:solidFill>
-            <a:srgbClr val="F0F4FF"/>
+            <a:srgbClr val="E0E7FF"/>
           </a:solidFill>
           <a:ln>
             <a:noFill/>
@@ -4864,7 +4864,7 @@
             <a:r>
               <a:rPr lang="uz-UZ" sz="1750" b="0" i="0" dirty="0">
                 <a:solidFill>
-                  <a:srgbClr val="1F2937"/>
+                  <a:srgbClr val="374151"/>
                 </a:solidFill>
               </a:rPr>
               <a:t>Mas'uliyatlilik, shaffoflik, doimiy o'rganish va etika — IT mutaxassisining asosi</a:t>
@@ -4889,7 +4889,7 @@
             </a:avLst>
           </a:prstGeom>
           <a:solidFill>
-            <a:srgbClr val="F0F4FF"/>
+            <a:srgbClr val="E0E7FF"/>
           </a:solidFill>
           <a:ln>
             <a:noFill/>
@@ -4990,7 +4990,7 @@
             <a:r>
               <a:rPr lang="uz-UZ" sz="1750" b="0" i="0" dirty="0">
                 <a:solidFill>
-                  <a:srgbClr val="1F2937"/>
+                  <a:srgbClr val="374151"/>
                 </a:solidFill>
               </a:rPr>
               <a:t>Tizimli 5 bosqich metodi murakkab texnik muammolarni samarali hal etishda ishladi</a:t>
@@ -5042,7 +5042,7 @@
             <a:avLst/>
           </a:prstGeom>
           <a:solidFill>
-            <a:srgbClr val="15803D"/>
+            <a:srgbClr val="059669"/>
           </a:solidFill>
           <a:ln>
             <a:noFill/>
@@ -5081,7 +5081,7 @@
             <a:r>
               <a:rPr lang="uz-UZ" sz="1800" b="1" i="0" dirty="0">
                 <a:solidFill>
-                  <a:srgbClr val="15803D"/>
+                  <a:srgbClr val="059669"/>
                 </a:solidFill>
               </a:rPr>
               <a:t>Ushbu loyiha menga texnik va kasbiy sifatda sezilarli o'sish imkonini berdi.</a:t>
@@ -5164,7 +5164,7 @@
             <a:avLst/>
           </a:prstGeom>
           <a:solidFill>
-            <a:srgbClr val="FFFFFF"/>
+            <a:srgbClr val="F8F9FF"/>
           </a:solidFill>
           <a:ln>
             <a:noFill/>
@@ -5185,13 +5185,13 @@
         <p:spPr>
           <a:xfrm>
             <a:off x="0" y="0"/>
-            <a:ext cx="12193200" cy="355600"/>
-          </a:xfrm>
-          <a:prstGeom prst="rect">
-            <a:avLst/>
-          </a:prstGeom>
-          <a:solidFill>
-            <a:srgbClr val="B8860B"/>
+            <a:ext cx="12193200" cy="406400"/>
+          </a:xfrm>
+          <a:prstGeom prst="rect">
+            <a:avLst/>
+          </a:prstGeom>
+          <a:solidFill>
+            <a:srgbClr val="D97706"/>
           </a:solidFill>
           <a:ln>
             <a:noFill/>
@@ -5211,14 +5211,14 @@
         </p:nvSpPr>
         <p:spPr>
           <a:xfrm>
-            <a:off x="0" y="6502400"/>
-            <a:ext cx="12193200" cy="355600"/>
-          </a:xfrm>
-          <a:prstGeom prst="rect">
-            <a:avLst/>
-          </a:prstGeom>
-          <a:solidFill>
-            <a:srgbClr val="B8860B"/>
+            <a:off x="0" y="6451600"/>
+            <a:ext cx="12193200" cy="406400"/>
+          </a:xfrm>
+          <a:prstGeom prst="rect">
+            <a:avLst/>
+          </a:prstGeom>
+          <a:solidFill>
+            <a:srgbClr val="D97706"/>
           </a:solidFill>
           <a:ln>
             <a:noFill/>
@@ -5238,14 +5238,14 @@
         </p:nvSpPr>
         <p:spPr>
           <a:xfrm>
-            <a:off x="0" y="355600"/>
-            <a:ext cx="127000" cy="6146800"/>
-          </a:xfrm>
-          <a:prstGeom prst="rect">
-            <a:avLst/>
-          </a:prstGeom>
-          <a:solidFill>
-            <a:srgbClr val="B8860B"/>
+            <a:off x="0" y="406400"/>
+            <a:ext cx="152400" cy="6045200"/>
+          </a:xfrm>
+          <a:prstGeom prst="rect">
+            <a:avLst/>
+          </a:prstGeom>
+          <a:solidFill>
+            <a:srgbClr val="D97706"/>
           </a:solidFill>
           <a:ln>
             <a:noFill/>
@@ -5272,7 +5272,7 @@
             <a:avLst/>
           </a:prstGeom>
           <a:solidFill>
-            <a:srgbClr val="B8860B"/>
+            <a:srgbClr val="D97706"/>
           </a:solidFill>
           <a:ln>
             <a:noFill/>
@@ -5311,7 +5311,7 @@
             <a:r>
               <a:rPr lang="uz-UZ" sz="2800" b="1" i="0" dirty="0">
                 <a:solidFill>
-                  <a:srgbClr val="111827"/>
+                  <a:srgbClr val="1E1B4B"/>
                 </a:solidFill>
               </a:rPr>
               <a:t>BAHOLASH MEZONLARI — D MAQSAD (13 BALL)</a:t>
@@ -5334,7 +5334,7 @@
             <a:avLst/>
           </a:prstGeom>
           <a:solidFill>
-            <a:srgbClr val="B8860B"/>
+            <a:srgbClr val="D97706"/>
           </a:solidFill>
           <a:ln>
             <a:noFill/>
@@ -5363,7 +5363,7 @@
             </a:avLst>
           </a:prstGeom>
           <a:solidFill>
-            <a:srgbClr val="F0F4FF"/>
+            <a:srgbClr val="E0E7FF"/>
           </a:solidFill>
           <a:ln>
             <a:noFill/>
@@ -5390,7 +5390,7 @@
             <a:avLst/>
           </a:prstGeom>
           <a:solidFill>
-            <a:srgbClr val="15803D"/>
+            <a:srgbClr val="059669"/>
           </a:solidFill>
           <a:ln>
             <a:noFill/>
@@ -5419,7 +5419,7 @@
             </a:avLst>
           </a:prstGeom>
           <a:solidFill>
-            <a:srgbClr val="15803D"/>
+            <a:srgbClr val="059669"/>
           </a:solidFill>
           <a:ln>
             <a:noFill/>
@@ -5493,7 +5493,7 @@
             <a:r>
               <a:rPr lang="uz-UZ" sz="1750" b="0" i="0" dirty="0">
                 <a:solidFill>
-                  <a:srgbClr val="1F2937"/>
+                  <a:srgbClr val="374151"/>
                 </a:solidFill>
               </a:rPr>
               <a:t>Loyihani doimiy yaxshi texnik tushunish</a:t>
@@ -5504,7 +5504,7 @@
             <a:r>
               <a:rPr lang="uz-UZ" sz="1750" b="0" i="0" dirty="0">
                 <a:solidFill>
-                  <a:srgbClr val="1F2937"/>
+                  <a:srgbClr val="374151"/>
                 </a:solidFill>
               </a:rPr>
               <a:t>va ko'nikmalarni samarali qo'llash</a:t>
@@ -5603,7 +5603,7 @@
             <a:r>
               <a:rPr lang="uz-UZ" sz="1600" b="1" i="0" dirty="0">
                 <a:solidFill>
-                  <a:srgbClr val="15803D"/>
+                  <a:srgbClr val="059669"/>
                 </a:solidFill>
               </a:rPr>
               <a:t>✅ BAJARILDI</a:t>
@@ -5628,7 +5628,7 @@
             </a:avLst>
           </a:prstGeom>
           <a:solidFill>
-            <a:srgbClr val="F0F4FF"/>
+            <a:srgbClr val="E0E7FF"/>
           </a:solidFill>
           <a:ln>
             <a:noFill/>
@@ -5655,7 +5655,7 @@
             <a:avLst/>
           </a:prstGeom>
           <a:solidFill>
-            <a:srgbClr val="1D4ED8"/>
+            <a:srgbClr val="2563EB"/>
           </a:solidFill>
           <a:ln>
             <a:noFill/>
@@ -5684,7 +5684,7 @@
             </a:avLst>
           </a:prstGeom>
           <a:solidFill>
-            <a:srgbClr val="1D4ED8"/>
+            <a:srgbClr val="2563EB"/>
           </a:solidFill>
           <a:ln>
             <a:noFill/>
@@ -5758,7 +5758,7 @@
             <a:r>
               <a:rPr lang="uz-UZ" sz="1750" b="0" i="0" dirty="0">
                 <a:solidFill>
-                  <a:srgbClr val="1F2937"/>
+                  <a:srgbClr val="374151"/>
                 </a:solidFill>
               </a:rPr>
               <a:t>AT loyihasi davomida qo'llaniladigan</a:t>
@@ -5769,7 +5769,7 @@
             <a:r>
               <a:rPr lang="uz-UZ" sz="1750" b="0" i="0" dirty="0">
                 <a:solidFill>
-                  <a:srgbClr val="1F2937"/>
+                  <a:srgbClr val="374151"/>
                 </a:solidFill>
               </a:rPr>
               <a:t>xatti-harakatlarni yaxshilashni tavsiya</a:t>
@@ -5868,7 +5868,7 @@
             <a:r>
               <a:rPr lang="uz-UZ" sz="1600" b="1" i="0" dirty="0">
                 <a:solidFill>
-                  <a:srgbClr val="15803D"/>
+                  <a:srgbClr val="059669"/>
                 </a:solidFill>
               </a:rPr>
               <a:t>✅ BAJARILDI</a:t>
@@ -5893,7 +5893,7 @@
             </a:avLst>
           </a:prstGeom>
           <a:solidFill>
-            <a:srgbClr val="F0F4FF"/>
+            <a:srgbClr val="E0E7FF"/>
           </a:solidFill>
           <a:ln>
             <a:noFill/>
@@ -5920,7 +5920,7 @@
             <a:avLst/>
           </a:prstGeom>
           <a:solidFill>
-            <a:srgbClr val="DC2626"/>
+            <a:srgbClr val="E11D48"/>
           </a:solidFill>
           <a:ln>
             <a:noFill/>
@@ -5949,7 +5949,7 @@
             </a:avLst>
           </a:prstGeom>
           <a:solidFill>
-            <a:srgbClr val="DC2626"/>
+            <a:srgbClr val="E11D48"/>
           </a:solidFill>
           <a:ln>
             <a:noFill/>
@@ -6023,7 +6023,7 @@
             <a:r>
               <a:rPr lang="uz-UZ" sz="1750" b="0" i="0" dirty="0">
                 <a:solidFill>
-                  <a:srgbClr val="1F2937"/>
+                  <a:srgbClr val="374151"/>
                 </a:solidFill>
               </a:rPr>
               <a:t>Loyiha boshqarish ko'nikmalaridan</a:t>
@@ -6034,7 +6034,7 @@
             <a:r>
               <a:rPr lang="uz-UZ" sz="1750" b="0" i="0" dirty="0">
                 <a:solidFill>
-                  <a:srgbClr val="1F2937"/>
+                  <a:srgbClr val="374151"/>
                 </a:solidFill>
               </a:rPr>
               <a:t>AT loyihasida foydalanganligini tushuntirish</a:t>
@@ -6133,7 +6133,7 @@
             <a:r>
               <a:rPr lang="uz-UZ" sz="1600" b="1" i="0" dirty="0">
                 <a:solidFill>
-                  <a:srgbClr val="15803D"/>
+                  <a:srgbClr val="059669"/>
                 </a:solidFill>
               </a:rPr>
               <a:t>✅ BAJARILDI</a:t>
@@ -6158,7 +6158,7 @@
             </a:avLst>
           </a:prstGeom>
           <a:solidFill>
-            <a:srgbClr val="F0F4FF"/>
+            <a:srgbClr val="E0E7FF"/>
           </a:solidFill>
           <a:ln>
             <a:noFill/>
@@ -6288,7 +6288,7 @@
             <a:r>
               <a:rPr lang="uz-UZ" sz="1750" b="0" i="0" dirty="0">
                 <a:solidFill>
-                  <a:srgbClr val="1F2937"/>
+                  <a:srgbClr val="374151"/>
                 </a:solidFill>
               </a:rPr>
               <a:t>AT loyihasini boshqarishda tegishli</a:t>
@@ -6299,7 +6299,7 @@
             <a:r>
               <a:rPr lang="uz-UZ" sz="1750" b="0" i="0" dirty="0">
                 <a:solidFill>
-                  <a:srgbClr val="1F2937"/>
+                  <a:srgbClr val="374151"/>
                 </a:solidFill>
               </a:rPr>
               <a:t>xatti-harakatlarni qo'llanganligini ko'rsatish</a:t>
@@ -6398,7 +6398,7 @@
             <a:r>
               <a:rPr lang="uz-UZ" sz="1600" b="1" i="0" dirty="0">
                 <a:solidFill>
-                  <a:srgbClr val="15803D"/>
+                  <a:srgbClr val="059669"/>
                 </a:solidFill>
               </a:rPr>
               <a:t>✅ BAJARILDI</a:t>
@@ -6450,7 +6450,7 @@
             <a:avLst/>
           </a:prstGeom>
           <a:solidFill>
-            <a:srgbClr val="B8860B"/>
+            <a:srgbClr val="D97706"/>
           </a:solidFill>
           <a:ln>
             <a:noFill/>
@@ -6489,7 +6489,7 @@
             <a:r>
               <a:rPr lang="uz-UZ" sz="1600" b="0" i="0" dirty="0">
                 <a:solidFill>
-                  <a:srgbClr val="B8860B"/>
+                  <a:srgbClr val="D97706"/>
                 </a:solidFill>
               </a:rPr>
               <a:t>Pearson | BTEC  ·  9-bo'lim LAD  ·  2-son  ·  2024 yil iyun  ·  D maqsad — 13 ball</a:t>
@@ -6572,7 +6572,7 @@
             <a:avLst/>
           </a:prstGeom>
           <a:solidFill>
-            <a:srgbClr val="FFFFFF"/>
+            <a:srgbClr val="F8F9FF"/>
           </a:solidFill>
           <a:ln>
             <a:noFill/>
@@ -6593,13 +6593,13 @@
         <p:spPr>
           <a:xfrm>
             <a:off x="0" y="0"/>
-            <a:ext cx="12193200" cy="355600"/>
-          </a:xfrm>
-          <a:prstGeom prst="rect">
-            <a:avLst/>
-          </a:prstGeom>
-          <a:solidFill>
-            <a:srgbClr val="1D4ED8"/>
+            <a:ext cx="12193200" cy="406400"/>
+          </a:xfrm>
+          <a:prstGeom prst="rect">
+            <a:avLst/>
+          </a:prstGeom>
+          <a:solidFill>
+            <a:srgbClr val="2563EB"/>
           </a:solidFill>
           <a:ln>
             <a:noFill/>
@@ -6619,14 +6619,14 @@
         </p:nvSpPr>
         <p:spPr>
           <a:xfrm>
-            <a:off x="0" y="6502400"/>
-            <a:ext cx="12193200" cy="355600"/>
-          </a:xfrm>
-          <a:prstGeom prst="rect">
-            <a:avLst/>
-          </a:prstGeom>
-          <a:solidFill>
-            <a:srgbClr val="1D4ED8"/>
+            <a:off x="0" y="6451600"/>
+            <a:ext cx="12193200" cy="406400"/>
+          </a:xfrm>
+          <a:prstGeom prst="rect">
+            <a:avLst/>
+          </a:prstGeom>
+          <a:solidFill>
+            <a:srgbClr val="2563EB"/>
           </a:solidFill>
           <a:ln>
             <a:noFill/>
@@ -6646,14 +6646,14 @@
         </p:nvSpPr>
         <p:spPr>
           <a:xfrm>
-            <a:off x="0" y="355600"/>
-            <a:ext cx="127000" cy="6146800"/>
-          </a:xfrm>
-          <a:prstGeom prst="rect">
-            <a:avLst/>
-          </a:prstGeom>
-          <a:solidFill>
-            <a:srgbClr val="1D4ED8"/>
+            <a:off x="0" y="406400"/>
+            <a:ext cx="152400" cy="6045200"/>
+          </a:xfrm>
+          <a:prstGeom prst="rect">
+            <a:avLst/>
+          </a:prstGeom>
+          <a:solidFill>
+            <a:srgbClr val="2563EB"/>
           </a:solidFill>
           <a:ln>
             <a:noFill/>
@@ -6680,7 +6680,7 @@
             <a:avLst/>
           </a:prstGeom>
           <a:solidFill>
-            <a:srgbClr val="1D4ED8"/>
+            <a:srgbClr val="2563EB"/>
           </a:solidFill>
           <a:ln>
             <a:noFill/>
@@ -6719,7 +6719,7 @@
             <a:r>
               <a:rPr lang="uz-UZ" sz="3200" b="1" i="0" dirty="0">
                 <a:solidFill>
-                  <a:srgbClr val="111827"/>
+                  <a:srgbClr val="1E1B4B"/>
                 </a:solidFill>
               </a:rPr>
               <a:t>MUNDARIJA</a:t>
@@ -6742,7 +6742,7 @@
             <a:avLst/>
           </a:prstGeom>
           <a:solidFill>
-            <a:srgbClr val="1D4ED8"/>
+            <a:srgbClr val="2563EB"/>
           </a:solidFill>
           <a:ln>
             <a:noFill/>
@@ -6771,7 +6771,7 @@
             </a:avLst>
           </a:prstGeom>
           <a:solidFill>
-            <a:srgbClr val="F0F4FF"/>
+            <a:srgbClr val="E0E7FF"/>
           </a:solidFill>
           <a:ln>
             <a:noFill/>
@@ -6798,7 +6798,7 @@
             <a:avLst/>
           </a:prstGeom>
           <a:solidFill>
-            <a:srgbClr val="1D4ED8"/>
+            <a:srgbClr val="2563EB"/>
           </a:solidFill>
           <a:ln>
             <a:noFill/>
@@ -6837,7 +6837,7 @@
             <a:r>
               <a:rPr lang="uz-UZ" sz="2600" b="1" i="0" dirty="0">
                 <a:solidFill>
-                  <a:srgbClr val="1D4ED8"/>
+                  <a:srgbClr val="2563EB"/>
                 </a:solidFill>
               </a:rPr>
               <a:t>01</a:t>
@@ -6872,7 +6872,7 @@
             <a:r>
               <a:rPr lang="uz-UZ" sz="1900" b="0" i="0" dirty="0">
                 <a:solidFill>
-                  <a:srgbClr val="1F2937"/>
+                  <a:srgbClr val="374151"/>
                 </a:solidFill>
               </a:rPr>
               <a:t>Loyiha haqida umumiy ma'lumot</a:t>
@@ -6897,7 +6897,7 @@
             </a:avLst>
           </a:prstGeom>
           <a:solidFill>
-            <a:srgbClr val="F0F4FF"/>
+            <a:srgbClr val="E0E7FF"/>
           </a:solidFill>
           <a:ln>
             <a:noFill/>
@@ -6924,7 +6924,7 @@
             <a:avLst/>
           </a:prstGeom>
           <a:solidFill>
-            <a:srgbClr val="1D4ED8"/>
+            <a:srgbClr val="2563EB"/>
           </a:solidFill>
           <a:ln>
             <a:noFill/>
@@ -6963,7 +6963,7 @@
             <a:r>
               <a:rPr lang="uz-UZ" sz="2600" b="1" i="0" dirty="0">
                 <a:solidFill>
-                  <a:srgbClr val="1D4ED8"/>
+                  <a:srgbClr val="2563EB"/>
                 </a:solidFill>
               </a:rPr>
               <a:t>02</a:t>
@@ -6998,7 +6998,7 @@
             <a:r>
               <a:rPr lang="uz-UZ" sz="1900" b="0" i="0" dirty="0">
                 <a:solidFill>
-                  <a:srgbClr val="1F2937"/>
+                  <a:srgbClr val="374151"/>
                 </a:solidFill>
               </a:rPr>
               <a:t>Dasturning ishlash mexanizmi</a:t>
@@ -7023,7 +7023,7 @@
             </a:avLst>
           </a:prstGeom>
           <a:solidFill>
-            <a:srgbClr val="F0F4FF"/>
+            <a:srgbClr val="E0E7FF"/>
           </a:solidFill>
           <a:ln>
             <a:noFill/>
@@ -7050,7 +7050,7 @@
             <a:avLst/>
           </a:prstGeom>
           <a:solidFill>
-            <a:srgbClr val="1D4ED8"/>
+            <a:srgbClr val="2563EB"/>
           </a:solidFill>
           <a:ln>
             <a:noFill/>
@@ -7089,7 +7089,7 @@
             <a:r>
               <a:rPr lang="uz-UZ" sz="2600" b="1" i="0" dirty="0">
                 <a:solidFill>
-                  <a:srgbClr val="1D4ED8"/>
+                  <a:srgbClr val="2563EB"/>
                 </a:solidFill>
               </a:rPr>
               <a:t>03</a:t>
@@ -7124,7 +7124,7 @@
             <a:r>
               <a:rPr lang="uz-UZ" sz="1900" b="0" i="0" dirty="0">
                 <a:solidFill>
-                  <a:srgbClr val="1F2937"/>
+                  <a:srgbClr val="374151"/>
                 </a:solidFill>
               </a:rPr>
               <a:t>DD 4 — Texnik ko'nikmalarni qo'llash</a:t>
@@ -7149,7 +7149,7 @@
             </a:avLst>
           </a:prstGeom>
           <a:solidFill>
-            <a:srgbClr val="F0F4FF"/>
+            <a:srgbClr val="E0E7FF"/>
           </a:solidFill>
           <a:ln>
             <a:noFill/>
@@ -7176,7 +7176,7 @@
             <a:avLst/>
           </a:prstGeom>
           <a:solidFill>
-            <a:srgbClr val="1D4ED8"/>
+            <a:srgbClr val="2563EB"/>
           </a:solidFill>
           <a:ln>
             <a:noFill/>
@@ -7215,7 +7215,7 @@
             <a:r>
               <a:rPr lang="uz-UZ" sz="2600" b="1" i="0" dirty="0">
                 <a:solidFill>
-                  <a:srgbClr val="1D4ED8"/>
+                  <a:srgbClr val="2563EB"/>
                 </a:solidFill>
               </a:rPr>
               <a:t>04</a:t>
@@ -7250,7 +7250,7 @@
             <a:r>
               <a:rPr lang="uz-UZ" sz="1900" b="0" i="0" dirty="0">
                 <a:solidFill>
-                  <a:srgbClr val="1F2937"/>
+                  <a:srgbClr val="374151"/>
                 </a:solidFill>
               </a:rPr>
               <a:t>D.M4 — Xatti-harakatlarni yaxshilash tavsiyalari</a:t>
@@ -7275,7 +7275,7 @@
             </a:avLst>
           </a:prstGeom>
           <a:solidFill>
-            <a:srgbClr val="F0F4FF"/>
+            <a:srgbClr val="E0E7FF"/>
           </a:solidFill>
           <a:ln>
             <a:noFill/>
@@ -7302,7 +7302,7 @@
             <a:avLst/>
           </a:prstGeom>
           <a:solidFill>
-            <a:srgbClr val="1D4ED8"/>
+            <a:srgbClr val="2563EB"/>
           </a:solidFill>
           <a:ln>
             <a:noFill/>
@@ -7341,7 +7341,7 @@
             <a:r>
               <a:rPr lang="uz-UZ" sz="2600" b="1" i="0" dirty="0">
                 <a:solidFill>
-                  <a:srgbClr val="1D4ED8"/>
+                  <a:srgbClr val="2563EB"/>
                 </a:solidFill>
               </a:rPr>
               <a:t>05</a:t>
@@ -7376,7 +7376,7 @@
             <a:r>
               <a:rPr lang="uz-UZ" sz="1900" b="0" i="0" dirty="0">
                 <a:solidFill>
-                  <a:srgbClr val="1F2937"/>
+                  <a:srgbClr val="374151"/>
                 </a:solidFill>
               </a:rPr>
               <a:t>DP 8 — Loyiha boshqarish ko'nikmalari</a:t>
@@ -7401,7 +7401,7 @@
             </a:avLst>
           </a:prstGeom>
           <a:solidFill>
-            <a:srgbClr val="F0F4FF"/>
+            <a:srgbClr val="E0E7FF"/>
           </a:solidFill>
           <a:ln>
             <a:noFill/>
@@ -7428,7 +7428,7 @@
             <a:avLst/>
           </a:prstGeom>
           <a:solidFill>
-            <a:srgbClr val="1D4ED8"/>
+            <a:srgbClr val="2563EB"/>
           </a:solidFill>
           <a:ln>
             <a:noFill/>
@@ -7467,7 +7467,7 @@
             <a:r>
               <a:rPr lang="uz-UZ" sz="2600" b="1" i="0" dirty="0">
                 <a:solidFill>
-                  <a:srgbClr val="1D4ED8"/>
+                  <a:srgbClr val="2563EB"/>
                 </a:solidFill>
               </a:rPr>
               <a:t>06</a:t>
@@ -7502,7 +7502,7 @@
             <a:r>
               <a:rPr lang="uz-UZ" sz="1900" b="0" i="0" dirty="0">
                 <a:solidFill>
-                  <a:srgbClr val="1F2937"/>
+                  <a:srgbClr val="374151"/>
                 </a:solidFill>
               </a:rPr>
               <a:t>DP 9 — Kasbiy xatti-harakatlar</a:t>
@@ -7527,7 +7527,7 @@
             </a:avLst>
           </a:prstGeom>
           <a:solidFill>
-            <a:srgbClr val="F0F4FF"/>
+            <a:srgbClr val="E0E7FF"/>
           </a:solidFill>
           <a:ln>
             <a:noFill/>
@@ -7554,7 +7554,7 @@
             <a:avLst/>
           </a:prstGeom>
           <a:solidFill>
-            <a:srgbClr val="1D4ED8"/>
+            <a:srgbClr val="2563EB"/>
           </a:solidFill>
           <a:ln>
             <a:noFill/>
@@ -7593,7 +7593,7 @@
             <a:r>
               <a:rPr lang="uz-UZ" sz="2600" b="1" i="0" dirty="0">
                 <a:solidFill>
-                  <a:srgbClr val="1D4ED8"/>
+                  <a:srgbClr val="2563EB"/>
                 </a:solidFill>
               </a:rPr>
               <a:t>07</a:t>
@@ -7628,7 +7628,7 @@
             <a:r>
               <a:rPr lang="uz-UZ" sz="1900" b="0" i="0" dirty="0">
                 <a:solidFill>
-                  <a:srgbClr val="1F2937"/>
+                  <a:srgbClr val="374151"/>
                 </a:solidFill>
               </a:rPr>
               <a:t>Natijalar va xulosa</a:t>
@@ -7711,7 +7711,7 @@
             <a:avLst/>
           </a:prstGeom>
           <a:solidFill>
-            <a:srgbClr val="FFFFFF"/>
+            <a:srgbClr val="F8F9FF"/>
           </a:solidFill>
           <a:ln>
             <a:noFill/>
@@ -7732,13 +7732,13 @@
         <p:spPr>
           <a:xfrm>
             <a:off x="0" y="0"/>
-            <a:ext cx="12193200" cy="355600"/>
-          </a:xfrm>
-          <a:prstGeom prst="rect">
-            <a:avLst/>
-          </a:prstGeom>
-          <a:solidFill>
-            <a:srgbClr val="B8860B"/>
+            <a:ext cx="12193200" cy="406400"/>
+          </a:xfrm>
+          <a:prstGeom prst="rect">
+            <a:avLst/>
+          </a:prstGeom>
+          <a:solidFill>
+            <a:srgbClr val="D97706"/>
           </a:solidFill>
           <a:ln>
             <a:noFill/>
@@ -7758,14 +7758,14 @@
         </p:nvSpPr>
         <p:spPr>
           <a:xfrm>
-            <a:off x="0" y="6502400"/>
-            <a:ext cx="12193200" cy="355600"/>
-          </a:xfrm>
-          <a:prstGeom prst="rect">
-            <a:avLst/>
-          </a:prstGeom>
-          <a:solidFill>
-            <a:srgbClr val="B8860B"/>
+            <a:off x="0" y="6451600"/>
+            <a:ext cx="12193200" cy="406400"/>
+          </a:xfrm>
+          <a:prstGeom prst="rect">
+            <a:avLst/>
+          </a:prstGeom>
+          <a:solidFill>
+            <a:srgbClr val="D97706"/>
           </a:solidFill>
           <a:ln>
             <a:noFill/>
@@ -7785,14 +7785,14 @@
         </p:nvSpPr>
         <p:spPr>
           <a:xfrm>
-            <a:off x="0" y="355600"/>
-            <a:ext cx="127000" cy="6146800"/>
-          </a:xfrm>
-          <a:prstGeom prst="rect">
-            <a:avLst/>
-          </a:prstGeom>
-          <a:solidFill>
-            <a:srgbClr val="B8860B"/>
+            <a:off x="0" y="406400"/>
+            <a:ext cx="152400" cy="6045200"/>
+          </a:xfrm>
+          <a:prstGeom prst="rect">
+            <a:avLst/>
+          </a:prstGeom>
+          <a:solidFill>
+            <a:srgbClr val="D97706"/>
           </a:solidFill>
           <a:ln>
             <a:noFill/>
@@ -7819,7 +7819,7 @@
             <a:avLst/>
           </a:prstGeom>
           <a:solidFill>
-            <a:srgbClr val="B8860B"/>
+            <a:srgbClr val="D97706"/>
           </a:solidFill>
           <a:ln>
             <a:noFill/>
@@ -7858,7 +7858,7 @@
             <a:r>
               <a:rPr lang="uz-UZ" sz="2800" b="1" i="0" dirty="0">
                 <a:solidFill>
-                  <a:srgbClr val="111827"/>
+                  <a:srgbClr val="1E1B4B"/>
                 </a:solidFill>
               </a:rPr>
               <a:t>01  |  LOYIHA HAQIDA UMUMIY MA'LUMOT</a:t>
@@ -7881,7 +7881,7 @@
             <a:avLst/>
           </a:prstGeom>
           <a:solidFill>
-            <a:srgbClr val="B8860B"/>
+            <a:srgbClr val="D97706"/>
           </a:solidFill>
           <a:ln>
             <a:noFill/>
@@ -7910,7 +7910,7 @@
             </a:avLst>
           </a:prstGeom>
           <a:solidFill>
-            <a:srgbClr val="F0F4FF"/>
+            <a:srgbClr val="E0E7FF"/>
           </a:solidFill>
           <a:ln>
             <a:noFill/>
@@ -7937,7 +7937,7 @@
             <a:avLst/>
           </a:prstGeom>
           <a:solidFill>
-            <a:srgbClr val="B8860B"/>
+            <a:srgbClr val="D97706"/>
           </a:solidFill>
           <a:ln>
             <a:noFill/>
@@ -7976,7 +7976,7 @@
             <a:r>
               <a:rPr lang="uz-UZ" sz="1900" b="0" i="0" dirty="0">
                 <a:solidFill>
-                  <a:srgbClr val="1F2937"/>
+                  <a:srgbClr val="374151"/>
                 </a:solidFill>
               </a:rPr>
               <a:t>Yangi dasturiy ta'minot kompaniyasida IT mutaxassisi sifatida</a:t>
@@ -7987,7 +7987,7 @@
             <a:r>
               <a:rPr lang="uz-UZ" sz="1900" b="0" i="0" dirty="0">
                 <a:solidFill>
-                  <a:srgbClr val="1F2937"/>
+                  <a:srgbClr val="374151"/>
                 </a:solidFill>
               </a:rPr>
               <a:t>ishga qabul qilindim. Loyiha — Kompyuter Tizimi Monitor Dasturi</a:t>
@@ -7998,7 +7998,7 @@
             <a:r>
               <a:rPr lang="uz-UZ" sz="1900" b="0" i="0" dirty="0">
                 <a:solidFill>
-                  <a:srgbClr val="1F2937"/>
+                  <a:srgbClr val="374151"/>
                 </a:solidFill>
               </a:rPr>
               <a:t>(KTMD) — yakunlangandan so'ng ushbu hisobot tayyorlandi.</a:t>
@@ -8023,7 +8023,7 @@
             </a:avLst>
           </a:prstGeom>
           <a:solidFill>
-            <a:srgbClr val="F0F4FF"/>
+            <a:srgbClr val="E0E7FF"/>
           </a:solidFill>
           <a:ln>
             <a:noFill/>
@@ -8050,7 +8050,7 @@
             <a:avLst/>
           </a:prstGeom>
           <a:solidFill>
-            <a:srgbClr val="B8860B"/>
+            <a:srgbClr val="D97706"/>
           </a:solidFill>
           <a:ln>
             <a:noFill/>
@@ -8089,7 +8089,7 @@
             <a:r>
               <a:rPr lang="uz-UZ" sz="3400" b="1" i="0" dirty="0">
                 <a:solidFill>
-                  <a:srgbClr val="B8860B"/>
+                  <a:srgbClr val="D97706"/>
                 </a:solidFill>
               </a:rPr>
               <a:t>KTMD v1.0</a:t>
@@ -8124,7 +8124,7 @@
             <a:r>
               <a:rPr lang="uz-UZ" sz="1600" b="0" i="0" dirty="0">
                 <a:solidFill>
-                  <a:srgbClr val="1F2937"/>
+                  <a:srgbClr val="374151"/>
                 </a:solidFill>
               </a:rPr>
               <a:t>Dastur nomi</a:t>
@@ -8149,7 +8149,7 @@
             </a:avLst>
           </a:prstGeom>
           <a:solidFill>
-            <a:srgbClr val="F0F4FF"/>
+            <a:srgbClr val="E0E7FF"/>
           </a:solidFill>
           <a:ln>
             <a:noFill/>
@@ -8176,7 +8176,7 @@
             <a:avLst/>
           </a:prstGeom>
           <a:solidFill>
-            <a:srgbClr val="1D4ED8"/>
+            <a:srgbClr val="2563EB"/>
           </a:solidFill>
           <a:ln>
             <a:noFill/>
@@ -8215,7 +8215,7 @@
             <a:r>
               <a:rPr lang="uz-UZ" sz="3400" b="1" i="0" dirty="0">
                 <a:solidFill>
-                  <a:srgbClr val="1D4ED8"/>
+                  <a:srgbClr val="2563EB"/>
                 </a:solidFill>
               </a:rPr>
               <a:t>8 hafta</a:t>
@@ -8250,7 +8250,7 @@
             <a:r>
               <a:rPr lang="uz-UZ" sz="1600" b="0" i="0" dirty="0">
                 <a:solidFill>
-                  <a:srgbClr val="1F2937"/>
+                  <a:srgbClr val="374151"/>
                 </a:solidFill>
               </a:rPr>
               <a:t>Loyiha muddati</a:t>
@@ -8275,7 +8275,7 @@
             </a:avLst>
           </a:prstGeom>
           <a:solidFill>
-            <a:srgbClr val="F0F4FF"/>
+            <a:srgbClr val="E0E7FF"/>
           </a:solidFill>
           <a:ln>
             <a:noFill/>
@@ -8302,7 +8302,7 @@
             <a:avLst/>
           </a:prstGeom>
           <a:solidFill>
-            <a:srgbClr val="15803D"/>
+            <a:srgbClr val="059669"/>
           </a:solidFill>
           <a:ln>
             <a:noFill/>
@@ -8341,7 +8341,7 @@
             <a:r>
               <a:rPr lang="uz-UZ" sz="3400" b="1" i="0" dirty="0">
                 <a:solidFill>
-                  <a:srgbClr val="15803D"/>
+                  <a:srgbClr val="059669"/>
                 </a:solidFill>
               </a:rPr>
               <a:t>13 ball</a:t>
@@ -8376,7 +8376,7 @@
             <a:r>
               <a:rPr lang="uz-UZ" sz="1600" b="0" i="0" dirty="0">
                 <a:solidFill>
-                  <a:srgbClr val="1F2937"/>
+                  <a:srgbClr val="374151"/>
                 </a:solidFill>
               </a:rPr>
               <a:t>D maqsad</a:t>
@@ -8401,7 +8401,7 @@
             </a:avLst>
           </a:prstGeom>
           <a:solidFill>
-            <a:srgbClr val="F0F4FF"/>
+            <a:srgbClr val="E0E7FF"/>
           </a:solidFill>
           <a:ln>
             <a:noFill/>
@@ -8428,7 +8428,7 @@
             <a:avLst/>
           </a:prstGeom>
           <a:solidFill>
-            <a:srgbClr val="DC2626"/>
+            <a:srgbClr val="E11D48"/>
           </a:solidFill>
           <a:ln>
             <a:noFill/>
@@ -8467,7 +8467,7 @@
             <a:r>
               <a:rPr lang="uz-UZ" sz="3400" b="1" i="0" dirty="0">
                 <a:solidFill>
-                  <a:srgbClr val="DC2626"/>
+                  <a:srgbClr val="E11D48"/>
                 </a:solidFill>
               </a:rPr>
               <a:t>6 modul</a:t>
@@ -8502,7 +8502,7 @@
             <a:r>
               <a:rPr lang="uz-UZ" sz="1600" b="0" i="0" dirty="0">
                 <a:solidFill>
-                  <a:srgbClr val="1F2937"/>
+                  <a:srgbClr val="374151"/>
                 </a:solidFill>
               </a:rPr>
               <a:t>Tarkibiy qismlar</a:t>
@@ -8620,7 +8620,7 @@
             <a:avLst/>
           </a:prstGeom>
           <a:solidFill>
-            <a:srgbClr val="FFFFFF"/>
+            <a:srgbClr val="F8F9FF"/>
           </a:solidFill>
           <a:ln>
             <a:noFill/>
@@ -8641,13 +8641,13 @@
         <p:spPr>
           <a:xfrm>
             <a:off x="0" y="0"/>
-            <a:ext cx="12193200" cy="355600"/>
-          </a:xfrm>
-          <a:prstGeom prst="rect">
-            <a:avLst/>
-          </a:prstGeom>
-          <a:solidFill>
-            <a:srgbClr val="1D4ED8"/>
+            <a:ext cx="12193200" cy="406400"/>
+          </a:xfrm>
+          <a:prstGeom prst="rect">
+            <a:avLst/>
+          </a:prstGeom>
+          <a:solidFill>
+            <a:srgbClr val="2563EB"/>
           </a:solidFill>
           <a:ln>
             <a:noFill/>
@@ -8667,14 +8667,14 @@
         </p:nvSpPr>
         <p:spPr>
           <a:xfrm>
-            <a:off x="0" y="6502400"/>
-            <a:ext cx="12193200" cy="355600"/>
-          </a:xfrm>
-          <a:prstGeom prst="rect">
-            <a:avLst/>
-          </a:prstGeom>
-          <a:solidFill>
-            <a:srgbClr val="1D4ED8"/>
+            <a:off x="0" y="6451600"/>
+            <a:ext cx="12193200" cy="406400"/>
+          </a:xfrm>
+          <a:prstGeom prst="rect">
+            <a:avLst/>
+          </a:prstGeom>
+          <a:solidFill>
+            <a:srgbClr val="2563EB"/>
           </a:solidFill>
           <a:ln>
             <a:noFill/>
@@ -8694,14 +8694,14 @@
         </p:nvSpPr>
         <p:spPr>
           <a:xfrm>
-            <a:off x="0" y="355600"/>
-            <a:ext cx="127000" cy="6146800"/>
-          </a:xfrm>
-          <a:prstGeom prst="rect">
-            <a:avLst/>
-          </a:prstGeom>
-          <a:solidFill>
-            <a:srgbClr val="1D4ED8"/>
+            <a:off x="0" y="406400"/>
+            <a:ext cx="152400" cy="6045200"/>
+          </a:xfrm>
+          <a:prstGeom prst="rect">
+            <a:avLst/>
+          </a:prstGeom>
+          <a:solidFill>
+            <a:srgbClr val="2563EB"/>
           </a:solidFill>
           <a:ln>
             <a:noFill/>
@@ -8728,7 +8728,7 @@
             <a:avLst/>
           </a:prstGeom>
           <a:solidFill>
-            <a:srgbClr val="1D4ED8"/>
+            <a:srgbClr val="2563EB"/>
           </a:solidFill>
           <a:ln>
             <a:noFill/>
@@ -8767,7 +8767,7 @@
             <a:r>
               <a:rPr lang="uz-UZ" sz="2800" b="1" i="0" dirty="0">
                 <a:solidFill>
-                  <a:srgbClr val="111827"/>
+                  <a:srgbClr val="1E1B4B"/>
                 </a:solidFill>
               </a:rPr>
               <a:t>02  |  DASTURNING ISHLASH MEXANIZMI</a:t>
@@ -8790,7 +8790,7 @@
             <a:avLst/>
           </a:prstGeom>
           <a:solidFill>
-            <a:srgbClr val="1D4ED8"/>
+            <a:srgbClr val="2563EB"/>
           </a:solidFill>
           <a:ln>
             <a:noFill/>
@@ -8819,7 +8819,7 @@
             </a:avLst>
           </a:prstGeom>
           <a:solidFill>
-            <a:srgbClr val="F0F4FF"/>
+            <a:srgbClr val="E0E7FF"/>
           </a:solidFill>
           <a:ln>
             <a:noFill/>
@@ -8846,7 +8846,7 @@
             <a:avLst/>
           </a:prstGeom>
           <a:solidFill>
-            <a:srgbClr val="B8860B"/>
+            <a:srgbClr val="D97706"/>
           </a:solidFill>
           <a:ln>
             <a:noFill/>
@@ -8875,7 +8875,7 @@
             </a:avLst>
           </a:prstGeom>
           <a:solidFill>
-            <a:srgbClr val="B8860B"/>
+            <a:srgbClr val="D97706"/>
           </a:solidFill>
           <a:ln>
             <a:noFill/>
@@ -8949,7 +8949,7 @@
             <a:r>
               <a:rPr lang="uz-UZ" sz="2000" b="1" i="0" dirty="0">
                 <a:solidFill>
-                  <a:srgbClr val="B8860B"/>
+                  <a:srgbClr val="D97706"/>
                 </a:solidFill>
               </a:rPr>
               <a:t>LOGIN</a:t>
@@ -8984,7 +8984,7 @@
             <a:r>
               <a:rPr lang="uz-UZ" sz="1700" b="0" i="0" dirty="0">
                 <a:solidFill>
-                  <a:srgbClr val="1F2937"/>
+                  <a:srgbClr val="374151"/>
                 </a:solidFill>
               </a:rPr>
               <a:t>SHA-256 shifrlash bilan autentifikatsiya</a:t>
@@ -9009,7 +9009,7 @@
             </a:avLst>
           </a:prstGeom>
           <a:solidFill>
-            <a:srgbClr val="F0F4FF"/>
+            <a:srgbClr val="E0E7FF"/>
           </a:solidFill>
           <a:ln>
             <a:noFill/>
@@ -9036,7 +9036,7 @@
             <a:avLst/>
           </a:prstGeom>
           <a:solidFill>
-            <a:srgbClr val="1D4ED8"/>
+            <a:srgbClr val="2563EB"/>
           </a:solidFill>
           <a:ln>
             <a:noFill/>
@@ -9065,7 +9065,7 @@
             </a:avLst>
           </a:prstGeom>
           <a:solidFill>
-            <a:srgbClr val="1D4ED8"/>
+            <a:srgbClr val="2563EB"/>
           </a:solidFill>
           <a:ln>
             <a:noFill/>
@@ -9139,7 +9139,7 @@
             <a:r>
               <a:rPr lang="uz-UZ" sz="2000" b="1" i="0" dirty="0">
                 <a:solidFill>
-                  <a:srgbClr val="1D4ED8"/>
+                  <a:srgbClr val="2563EB"/>
                 </a:solidFill>
               </a:rPr>
               <a:t>SKANERLASH</a:t>
@@ -9174,7 +9174,7 @@
             <a:r>
               <a:rPr lang="uz-UZ" sz="1700" b="0" i="0" dirty="0">
                 <a:solidFill>
-                  <a:srgbClr val="1F2937"/>
+                  <a:srgbClr val="374151"/>
                 </a:solidFill>
               </a:rPr>
               <a:t>Tarmoqda IP manzillarni aniqlash (Nmap)</a:t>
@@ -9199,7 +9199,7 @@
             </a:avLst>
           </a:prstGeom>
           <a:solidFill>
-            <a:srgbClr val="F0F4FF"/>
+            <a:srgbClr val="E0E7FF"/>
           </a:solidFill>
           <a:ln>
             <a:noFill/>
@@ -9226,7 +9226,7 @@
             <a:avLst/>
           </a:prstGeom>
           <a:solidFill>
-            <a:srgbClr val="15803D"/>
+            <a:srgbClr val="059669"/>
           </a:solidFill>
           <a:ln>
             <a:noFill/>
@@ -9255,7 +9255,7 @@
             </a:avLst>
           </a:prstGeom>
           <a:solidFill>
-            <a:srgbClr val="15803D"/>
+            <a:srgbClr val="059669"/>
           </a:solidFill>
           <a:ln>
             <a:noFill/>
@@ -9329,7 +9329,7 @@
             <a:r>
               <a:rPr lang="uz-UZ" sz="2000" b="1" i="0" dirty="0">
                 <a:solidFill>
-                  <a:srgbClr val="15803D"/>
+                  <a:srgbClr val="059669"/>
                 </a:solidFill>
               </a:rPr>
               <a:t>MONITORING</a:t>
@@ -9364,7 +9364,7 @@
             <a:r>
               <a:rPr lang="uz-UZ" sz="1700" b="0" i="0" dirty="0">
                 <a:solidFill>
-                  <a:srgbClr val="1F2937"/>
+                  <a:srgbClr val="374151"/>
                 </a:solidFill>
               </a:rPr>
               <a:t>CPU, RAM, Disk — har 5 soniyada o'lchash</a:t>
@@ -9389,7 +9389,7 @@
             </a:avLst>
           </a:prstGeom>
           <a:solidFill>
-            <a:srgbClr val="F0F4FF"/>
+            <a:srgbClr val="E0E7FF"/>
           </a:solidFill>
           <a:ln>
             <a:noFill/>
@@ -9416,7 +9416,7 @@
             <a:avLst/>
           </a:prstGeom>
           <a:solidFill>
-            <a:srgbClr val="DC2626"/>
+            <a:srgbClr val="E11D48"/>
           </a:solidFill>
           <a:ln>
             <a:noFill/>
@@ -9445,7 +9445,7 @@
             </a:avLst>
           </a:prstGeom>
           <a:solidFill>
-            <a:srgbClr val="DC2626"/>
+            <a:srgbClr val="E11D48"/>
           </a:solidFill>
           <a:ln>
             <a:noFill/>
@@ -9519,7 +9519,7 @@
             <a:r>
               <a:rPr lang="uz-UZ" sz="2000" b="1" i="0" dirty="0">
                 <a:solidFill>
-                  <a:srgbClr val="DC2626"/>
+                  <a:srgbClr val="E11D48"/>
                 </a:solidFill>
               </a:rPr>
               <a:t>OGOHLANTIRISH</a:t>
@@ -9554,7 +9554,7 @@
             <a:r>
               <a:rPr lang="uz-UZ" sz="1700" b="0" i="0" dirty="0">
                 <a:solidFill>
-                  <a:srgbClr val="1F2937"/>
+                  <a:srgbClr val="374151"/>
                 </a:solidFill>
               </a:rPr>
               <a:t>CPU&gt;90% yoki Disk&gt;95% da email yuborish</a:t>
@@ -9579,7 +9579,7 @@
             </a:avLst>
           </a:prstGeom>
           <a:solidFill>
-            <a:srgbClr val="F0F4FF"/>
+            <a:srgbClr val="E0E7FF"/>
           </a:solidFill>
           <a:ln>
             <a:noFill/>
@@ -9744,7 +9744,7 @@
             <a:r>
               <a:rPr lang="uz-UZ" sz="1700" b="0" i="0" dirty="0">
                 <a:solidFill>
-                  <a:srgbClr val="1F2937"/>
+                  <a:srgbClr val="374151"/>
                 </a:solidFill>
               </a:rPr>
               <a:t>Barcha ma'lumotlar SQLite bazasiga yoziladi</a:t>
@@ -9769,7 +9769,7 @@
             </a:avLst>
           </a:prstGeom>
           <a:solidFill>
-            <a:srgbClr val="F0F4FF"/>
+            <a:srgbClr val="E0E7FF"/>
           </a:solidFill>
           <a:ln>
             <a:noFill/>
@@ -9934,7 +9934,7 @@
             <a:r>
               <a:rPr lang="uz-UZ" sz="1700" b="0" i="0" dirty="0">
                 <a:solidFill>
-                  <a:srgbClr val="1F2937"/>
+                  <a:srgbClr val="374151"/>
                 </a:solidFill>
               </a:rPr>
               <a:t>PDF/Excel formatda avtomatik hisobot olish</a:t>
@@ -10017,7 +10017,7 @@
             <a:avLst/>
           </a:prstGeom>
           <a:solidFill>
-            <a:srgbClr val="FFFFFF"/>
+            <a:srgbClr val="F8F9FF"/>
           </a:solidFill>
           <a:ln>
             <a:noFill/>
@@ -10038,13 +10038,13 @@
         <p:spPr>
           <a:xfrm>
             <a:off x="0" y="0"/>
-            <a:ext cx="12193200" cy="355600"/>
-          </a:xfrm>
-          <a:prstGeom prst="rect">
-            <a:avLst/>
-          </a:prstGeom>
-          <a:solidFill>
-            <a:srgbClr val="B8860B"/>
+            <a:ext cx="12193200" cy="406400"/>
+          </a:xfrm>
+          <a:prstGeom prst="rect">
+            <a:avLst/>
+          </a:prstGeom>
+          <a:solidFill>
+            <a:srgbClr val="D97706"/>
           </a:solidFill>
           <a:ln>
             <a:noFill/>
@@ -10064,14 +10064,14 @@
         </p:nvSpPr>
         <p:spPr>
           <a:xfrm>
-            <a:off x="0" y="6502400"/>
-            <a:ext cx="12193200" cy="355600"/>
-          </a:xfrm>
-          <a:prstGeom prst="rect">
-            <a:avLst/>
-          </a:prstGeom>
-          <a:solidFill>
-            <a:srgbClr val="B8860B"/>
+            <a:off x="0" y="6451600"/>
+            <a:ext cx="12193200" cy="406400"/>
+          </a:xfrm>
+          <a:prstGeom prst="rect">
+            <a:avLst/>
+          </a:prstGeom>
+          <a:solidFill>
+            <a:srgbClr val="D97706"/>
           </a:solidFill>
           <a:ln>
             <a:noFill/>
@@ -10091,14 +10091,14 @@
         </p:nvSpPr>
         <p:spPr>
           <a:xfrm>
-            <a:off x="0" y="355600"/>
-            <a:ext cx="127000" cy="6146800"/>
-          </a:xfrm>
-          <a:prstGeom prst="rect">
-            <a:avLst/>
-          </a:prstGeom>
-          <a:solidFill>
-            <a:srgbClr val="B8860B"/>
+            <a:off x="0" y="406400"/>
+            <a:ext cx="152400" cy="6045200"/>
+          </a:xfrm>
+          <a:prstGeom prst="rect">
+            <a:avLst/>
+          </a:prstGeom>
+          <a:solidFill>
+            <a:srgbClr val="D97706"/>
           </a:solidFill>
           <a:ln>
             <a:noFill/>
@@ -10125,7 +10125,7 @@
             <a:avLst/>
           </a:prstGeom>
           <a:solidFill>
-            <a:srgbClr val="B8860B"/>
+            <a:srgbClr val="D97706"/>
           </a:solidFill>
           <a:ln>
             <a:noFill/>
@@ -10164,7 +10164,7 @@
             <a:r>
               <a:rPr lang="uz-UZ" sz="2800" b="1" i="0" dirty="0">
                 <a:solidFill>
-                  <a:srgbClr val="111827"/>
+                  <a:srgbClr val="1E1B4B"/>
                 </a:solidFill>
               </a:rPr>
               <a:t>02  |  DASTUR ARXITEKTURASI — MODULLAR</a:t>
@@ -10187,7 +10187,7 @@
             <a:avLst/>
           </a:prstGeom>
           <a:solidFill>
-            <a:srgbClr val="B8860B"/>
+            <a:srgbClr val="D97706"/>
           </a:solidFill>
           <a:ln>
             <a:noFill/>
@@ -10214,7 +10214,7 @@
             <a:avLst/>
           </a:prstGeom>
           <a:solidFill>
-            <a:srgbClr val="B8860B"/>
+            <a:srgbClr val="D97706"/>
           </a:solidFill>
           <a:ln>
             <a:noFill/>
@@ -10276,7 +10276,7 @@
             <a:avLst/>
           </a:prstGeom>
           <a:solidFill>
-            <a:srgbClr val="B8860B"/>
+            <a:srgbClr val="D97706"/>
           </a:solidFill>
           <a:ln>
             <a:noFill/>
@@ -10338,7 +10338,7 @@
             <a:avLst/>
           </a:prstGeom>
           <a:solidFill>
-            <a:srgbClr val="B8860B"/>
+            <a:srgbClr val="D97706"/>
           </a:solidFill>
           <a:ln>
             <a:noFill/>
@@ -10402,7 +10402,7 @@
             </a:avLst>
           </a:prstGeom>
           <a:solidFill>
-            <a:srgbClr val="F0F4FF"/>
+            <a:srgbClr val="E0E7FF"/>
           </a:solidFill>
           <a:ln>
             <a:noFill/>
@@ -10441,7 +10441,7 @@
             <a:r>
               <a:rPr lang="uz-UZ" sz="1700" b="1" i="0" dirty="0">
                 <a:solidFill>
-                  <a:srgbClr val="B8860B"/>
+                  <a:srgbClr val="D97706"/>
                 </a:solidFill>
               </a:rPr>
               <a:t>GUI Moduli</a:t>
@@ -10466,7 +10466,7 @@
             </a:avLst>
           </a:prstGeom>
           <a:solidFill>
-            <a:srgbClr val="F0F4FF"/>
+            <a:srgbClr val="E0E7FF"/>
           </a:solidFill>
           <a:ln>
             <a:noFill/>
@@ -10505,7 +10505,7 @@
             <a:r>
               <a:rPr lang="uz-UZ" sz="1700" b="0" i="0" dirty="0">
                 <a:solidFill>
-                  <a:srgbClr val="1F2937"/>
+                  <a:srgbClr val="374151"/>
                 </a:solidFill>
               </a:rPr>
               <a:t>Foydalanuvchi interfeysi, tugmalar, grafik</a:t>
@@ -10530,7 +10530,7 @@
             </a:avLst>
           </a:prstGeom>
           <a:solidFill>
-            <a:srgbClr val="F0F4FF"/>
+            <a:srgbClr val="E0E7FF"/>
           </a:solidFill>
           <a:ln>
             <a:noFill/>
@@ -10569,7 +10569,7 @@
             <a:r>
               <a:rPr lang="uz-UZ" sz="1700" b="0" i="0" dirty="0">
                 <a:solidFill>
-                  <a:srgbClr val="1F2937"/>
+                  <a:srgbClr val="374151"/>
                 </a:solidFill>
               </a:rPr>
               <a:t>Python Tkinter</a:t>
@@ -10594,7 +10594,7 @@
             </a:avLst>
           </a:prstGeom>
           <a:solidFill>
-            <a:srgbClr val="FFF8E1"/>
+            <a:srgbClr val="FEF9EC"/>
           </a:solidFill>
           <a:ln>
             <a:noFill/>
@@ -10633,7 +10633,7 @@
             <a:r>
               <a:rPr lang="uz-UZ" sz="1700" b="1" i="0" dirty="0">
                 <a:solidFill>
-                  <a:srgbClr val="B8860B"/>
+                  <a:srgbClr val="D97706"/>
                 </a:solidFill>
               </a:rPr>
               <a:t>Tarmoq Skaneri</a:t>
@@ -10658,7 +10658,7 @@
             </a:avLst>
           </a:prstGeom>
           <a:solidFill>
-            <a:srgbClr val="FFF8E1"/>
+            <a:srgbClr val="FEF9EC"/>
           </a:solidFill>
           <a:ln>
             <a:noFill/>
@@ -10697,7 +10697,7 @@
             <a:r>
               <a:rPr lang="uz-UZ" sz="1700" b="0" i="0" dirty="0">
                 <a:solidFill>
-                  <a:srgbClr val="1F2937"/>
+                  <a:srgbClr val="374151"/>
                 </a:solidFill>
               </a:rPr>
               <a:t>IP skanerlash, qurilmalarni aniqlash</a:t>
@@ -10722,7 +10722,7 @@
             </a:avLst>
           </a:prstGeom>
           <a:solidFill>
-            <a:srgbClr val="FFF8E1"/>
+            <a:srgbClr val="FEF9EC"/>
           </a:solidFill>
           <a:ln>
             <a:noFill/>
@@ -10761,7 +10761,7 @@
             <a:r>
               <a:rPr lang="uz-UZ" sz="1700" b="0" i="0" dirty="0">
                 <a:solidFill>
-                  <a:srgbClr val="1F2937"/>
+                  <a:srgbClr val="374151"/>
                 </a:solidFill>
               </a:rPr>
               <a:t>socket / nmap</a:t>
@@ -10786,7 +10786,7 @@
             </a:avLst>
           </a:prstGeom>
           <a:solidFill>
-            <a:srgbClr val="F0F4FF"/>
+            <a:srgbClr val="E0E7FF"/>
           </a:solidFill>
           <a:ln>
             <a:noFill/>
@@ -10825,7 +10825,7 @@
             <a:r>
               <a:rPr lang="uz-UZ" sz="1700" b="1" i="0" dirty="0">
                 <a:solidFill>
-                  <a:srgbClr val="B8860B"/>
+                  <a:srgbClr val="D97706"/>
                 </a:solidFill>
               </a:rPr>
               <a:t>Monitor Moduli</a:t>
@@ -10850,7 +10850,7 @@
             </a:avLst>
           </a:prstGeom>
           <a:solidFill>
-            <a:srgbClr val="F0F4FF"/>
+            <a:srgbClr val="E0E7FF"/>
           </a:solidFill>
           <a:ln>
             <a:noFill/>
@@ -10889,7 +10889,7 @@
             <a:r>
               <a:rPr lang="uz-UZ" sz="1700" b="0" i="0" dirty="0">
                 <a:solidFill>
-                  <a:srgbClr val="1F2937"/>
+                  <a:srgbClr val="374151"/>
                 </a:solidFill>
               </a:rPr>
               <a:t>CPU, RAM, Disk, Temperatura kuzatish</a:t>
@@ -10914,7 +10914,7 @@
             </a:avLst>
           </a:prstGeom>
           <a:solidFill>
-            <a:srgbClr val="F0F4FF"/>
+            <a:srgbClr val="E0E7FF"/>
           </a:solidFill>
           <a:ln>
             <a:noFill/>
@@ -10953,7 +10953,7 @@
             <a:r>
               <a:rPr lang="uz-UZ" sz="1700" b="0" i="0" dirty="0">
                 <a:solidFill>
-                  <a:srgbClr val="1F2937"/>
+                  <a:srgbClr val="374151"/>
                 </a:solidFill>
               </a:rPr>
               <a:t>psutil</a:t>
@@ -10978,7 +10978,7 @@
             </a:avLst>
           </a:prstGeom>
           <a:solidFill>
-            <a:srgbClr val="FFF8E1"/>
+            <a:srgbClr val="FEF9EC"/>
           </a:solidFill>
           <a:ln>
             <a:noFill/>
@@ -11017,7 +11017,7 @@
             <a:r>
               <a:rPr lang="uz-UZ" sz="1700" b="1" i="0" dirty="0">
                 <a:solidFill>
-                  <a:srgbClr val="B8860B"/>
+                  <a:srgbClr val="D97706"/>
                 </a:solidFill>
               </a:rPr>
               <a:t>Ma'lumotlar Bazasi</a:t>
@@ -11042,7 +11042,7 @@
             </a:avLst>
           </a:prstGeom>
           <a:solidFill>
-            <a:srgbClr val="FFF8E1"/>
+            <a:srgbClr val="FEF9EC"/>
           </a:solidFill>
           <a:ln>
             <a:noFill/>
@@ -11081,7 +11081,7 @@
             <a:r>
               <a:rPr lang="uz-UZ" sz="1700" b="0" i="0" dirty="0">
                 <a:solidFill>
-                  <a:srgbClr val="1F2937"/>
+                  <a:srgbClr val="374151"/>
                 </a:solidFill>
               </a:rPr>
               <a:t>Monitoring ma'lumotlarini saqlash</a:t>
@@ -11106,7 +11106,7 @@
             </a:avLst>
           </a:prstGeom>
           <a:solidFill>
-            <a:srgbClr val="FFF8E1"/>
+            <a:srgbClr val="FEF9EC"/>
           </a:solidFill>
           <a:ln>
             <a:noFill/>
@@ -11145,7 +11145,7 @@
             <a:r>
               <a:rPr lang="uz-UZ" sz="1700" b="0" i="0" dirty="0">
                 <a:solidFill>
-                  <a:srgbClr val="1F2937"/>
+                  <a:srgbClr val="374151"/>
                 </a:solidFill>
               </a:rPr>
               <a:t>SQLite3</a:t>
@@ -11170,7 +11170,7 @@
             </a:avLst>
           </a:prstGeom>
           <a:solidFill>
-            <a:srgbClr val="F0F4FF"/>
+            <a:srgbClr val="E0E7FF"/>
           </a:solidFill>
           <a:ln>
             <a:noFill/>
@@ -11209,7 +11209,7 @@
             <a:r>
               <a:rPr lang="uz-UZ" sz="1700" b="1" i="0" dirty="0">
                 <a:solidFill>
-                  <a:srgbClr val="B8860B"/>
+                  <a:srgbClr val="D97706"/>
                 </a:solidFill>
               </a:rPr>
               <a:t>Hisobot Generator</a:t>
@@ -11234,7 +11234,7 @@
             </a:avLst>
           </a:prstGeom>
           <a:solidFill>
-            <a:srgbClr val="F0F4FF"/>
+            <a:srgbClr val="E0E7FF"/>
           </a:solidFill>
           <a:ln>
             <a:noFill/>
@@ -11273,7 +11273,7 @@
             <a:r>
               <a:rPr lang="uz-UZ" sz="1700" b="0" i="0" dirty="0">
                 <a:solidFill>
-                  <a:srgbClr val="1F2937"/>
+                  <a:srgbClr val="374151"/>
                 </a:solidFill>
               </a:rPr>
               <a:t>PDF va Excel hisobotlar tayyorlash</a:t>
@@ -11298,7 +11298,7 @@
             </a:avLst>
           </a:prstGeom>
           <a:solidFill>
-            <a:srgbClr val="F0F4FF"/>
+            <a:srgbClr val="E0E7FF"/>
           </a:solidFill>
           <a:ln>
             <a:noFill/>
@@ -11337,7 +11337,7 @@
             <a:r>
               <a:rPr lang="uz-UZ" sz="1700" b="0" i="0" dirty="0">
                 <a:solidFill>
-                  <a:srgbClr val="1F2937"/>
+                  <a:srgbClr val="374151"/>
                 </a:solidFill>
               </a:rPr>
               <a:t>ReportLab / openpyxl</a:t>
@@ -11362,7 +11362,7 @@
             </a:avLst>
           </a:prstGeom>
           <a:solidFill>
-            <a:srgbClr val="FFF8E1"/>
+            <a:srgbClr val="FEF9EC"/>
           </a:solidFill>
           <a:ln>
             <a:noFill/>
@@ -11401,7 +11401,7 @@
             <a:r>
               <a:rPr lang="uz-UZ" sz="1700" b="1" i="0" dirty="0">
                 <a:solidFill>
-                  <a:srgbClr val="B8860B"/>
+                  <a:srgbClr val="D97706"/>
                 </a:solidFill>
               </a:rPr>
               <a:t>Ogohlantirish</a:t>
@@ -11426,7 +11426,7 @@
             </a:avLst>
           </a:prstGeom>
           <a:solidFill>
-            <a:srgbClr val="FFF8E1"/>
+            <a:srgbClr val="FEF9EC"/>
           </a:solidFill>
           <a:ln>
             <a:noFill/>
@@ -11465,7 +11465,7 @@
             <a:r>
               <a:rPr lang="uz-UZ" sz="1700" b="0" i="0" dirty="0">
                 <a:solidFill>
-                  <a:srgbClr val="1F2937"/>
+                  <a:srgbClr val="374151"/>
                 </a:solidFill>
               </a:rPr>
               <a:t>Kritik holatlarda email/SMS yuborish</a:t>
@@ -11490,7 +11490,7 @@
             </a:avLst>
           </a:prstGeom>
           <a:solidFill>
-            <a:srgbClr val="FFF8E1"/>
+            <a:srgbClr val="FEF9EC"/>
           </a:solidFill>
           <a:ln>
             <a:noFill/>
@@ -11529,7 +11529,7 @@
             <a:r>
               <a:rPr lang="uz-UZ" sz="1700" b="0" i="0" dirty="0">
                 <a:solidFill>
-                  <a:srgbClr val="1F2937"/>
+                  <a:srgbClr val="374151"/>
                 </a:solidFill>
               </a:rPr>
               <a:t>smtplib / Twilio</a:t>
@@ -11612,7 +11612,7 @@
             <a:avLst/>
           </a:prstGeom>
           <a:solidFill>
-            <a:srgbClr val="FFFFFF"/>
+            <a:srgbClr val="F8F9FF"/>
           </a:solidFill>
           <a:ln>
             <a:noFill/>
@@ -11633,13 +11633,13 @@
         <p:spPr>
           <a:xfrm>
             <a:off x="0" y="0"/>
-            <a:ext cx="12193200" cy="355600"/>
-          </a:xfrm>
-          <a:prstGeom prst="rect">
-            <a:avLst/>
-          </a:prstGeom>
-          <a:solidFill>
-            <a:srgbClr val="15803D"/>
+            <a:ext cx="12193200" cy="406400"/>
+          </a:xfrm>
+          <a:prstGeom prst="rect">
+            <a:avLst/>
+          </a:prstGeom>
+          <a:solidFill>
+            <a:srgbClr val="059669"/>
           </a:solidFill>
           <a:ln>
             <a:noFill/>
@@ -11659,14 +11659,14 @@
         </p:nvSpPr>
         <p:spPr>
           <a:xfrm>
-            <a:off x="0" y="6502400"/>
-            <a:ext cx="12193200" cy="355600"/>
-          </a:xfrm>
-          <a:prstGeom prst="rect">
-            <a:avLst/>
-          </a:prstGeom>
-          <a:solidFill>
-            <a:srgbClr val="15803D"/>
+            <a:off x="0" y="6451600"/>
+            <a:ext cx="12193200" cy="406400"/>
+          </a:xfrm>
+          <a:prstGeom prst="rect">
+            <a:avLst/>
+          </a:prstGeom>
+          <a:solidFill>
+            <a:srgbClr val="059669"/>
           </a:solidFill>
           <a:ln>
             <a:noFill/>
@@ -11686,14 +11686,14 @@
         </p:nvSpPr>
         <p:spPr>
           <a:xfrm>
-            <a:off x="0" y="355600"/>
-            <a:ext cx="127000" cy="6146800"/>
-          </a:xfrm>
-          <a:prstGeom prst="rect">
-            <a:avLst/>
-          </a:prstGeom>
-          <a:solidFill>
-            <a:srgbClr val="15803D"/>
+            <a:off x="0" y="406400"/>
+            <a:ext cx="152400" cy="6045200"/>
+          </a:xfrm>
+          <a:prstGeom prst="rect">
+            <a:avLst/>
+          </a:prstGeom>
+          <a:solidFill>
+            <a:srgbClr val="059669"/>
           </a:solidFill>
           <a:ln>
             <a:noFill/>
@@ -11720,7 +11720,7 @@
             <a:avLst/>
           </a:prstGeom>
           <a:solidFill>
-            <a:srgbClr val="15803D"/>
+            <a:srgbClr val="059669"/>
           </a:solidFill>
           <a:ln>
             <a:noFill/>
@@ -11749,7 +11749,7 @@
             </a:avLst>
           </a:prstGeom>
           <a:solidFill>
-            <a:srgbClr val="15803D"/>
+            <a:srgbClr val="059669"/>
           </a:solidFill>
           <a:ln>
             <a:noFill/>
@@ -11823,7 +11823,7 @@
             <a:r>
               <a:rPr lang="uz-UZ" sz="2200" b="1" i="0" dirty="0">
                 <a:solidFill>
-                  <a:srgbClr val="111827"/>
+                  <a:srgbClr val="1E1B4B"/>
                 </a:solidFill>
               </a:rPr>
               <a:t>Loyihani doimiy yaxshi texnik tushunish va ko'nikmalarni qo'llash</a:t>
@@ -11846,7 +11846,7 @@
             <a:avLst/>
           </a:prstGeom>
           <a:solidFill>
-            <a:srgbClr val="15803D"/>
+            <a:srgbClr val="059669"/>
           </a:solidFill>
           <a:ln>
             <a:noFill/>
@@ -11875,7 +11875,7 @@
             </a:avLst>
           </a:prstGeom>
           <a:solidFill>
-            <a:srgbClr val="F0F4FF"/>
+            <a:srgbClr val="E0E7FF"/>
           </a:solidFill>
           <a:ln>
             <a:noFill/>
@@ -11902,7 +11902,7 @@
             <a:avLst/>
           </a:prstGeom>
           <a:solidFill>
-            <a:srgbClr val="15803D"/>
+            <a:srgbClr val="059669"/>
           </a:solidFill>
           <a:ln>
             <a:noFill/>
@@ -11941,7 +11941,7 @@
             <a:r>
               <a:rPr lang="uz-UZ" sz="2000" b="1" i="0" dirty="0">
                 <a:solidFill>
-                  <a:srgbClr val="15803D"/>
+                  <a:srgbClr val="059669"/>
                 </a:solidFill>
               </a:rPr>
               <a:t>Tarmoq skanerlash</a:t>
@@ -11976,7 +11976,7 @@
             <a:r>
               <a:rPr lang="uz-UZ" sz="1700" b="0" i="0" dirty="0">
                 <a:solidFill>
-                  <a:srgbClr val="1F2937"/>
+                  <a:srgbClr val="374151"/>
                 </a:solidFill>
               </a:rPr>
               <a:t>Nmap bilan 150+ qurilmani aniqlash</a:t>
@@ -12001,7 +12001,7 @@
             </a:avLst>
           </a:prstGeom>
           <a:solidFill>
-            <a:srgbClr val="15803D"/>
+            <a:srgbClr val="059669"/>
           </a:solidFill>
           <a:ln>
             <a:noFill/>
@@ -12065,7 +12065,7 @@
             </a:avLst>
           </a:prstGeom>
           <a:solidFill>
-            <a:srgbClr val="F0F4FF"/>
+            <a:srgbClr val="E0E7FF"/>
           </a:solidFill>
           <a:ln>
             <a:noFill/>
@@ -12092,7 +12092,7 @@
             <a:avLst/>
           </a:prstGeom>
           <a:solidFill>
-            <a:srgbClr val="B8860B"/>
+            <a:srgbClr val="D97706"/>
           </a:solidFill>
           <a:ln>
             <a:noFill/>
@@ -12131,7 +12131,7 @@
             <a:r>
               <a:rPr lang="uz-UZ" sz="2000" b="1" i="0" dirty="0">
                 <a:solidFill>
-                  <a:srgbClr val="B8860B"/>
+                  <a:srgbClr val="D97706"/>
                 </a:solidFill>
               </a:rPr>
               <a:t>Python dasturlash</a:t>
@@ -12166,7 +12166,7 @@
             <a:r>
               <a:rPr lang="uz-UZ" sz="1700" b="0" i="0" dirty="0">
                 <a:solidFill>
-                  <a:srgbClr val="1F2937"/>
+                  <a:srgbClr val="374151"/>
                 </a:solidFill>
               </a:rPr>
               <a:t>Monitor va hisobot modullarini yozish</a:t>
@@ -12191,7 +12191,7 @@
             </a:avLst>
           </a:prstGeom>
           <a:solidFill>
-            <a:srgbClr val="B8860B"/>
+            <a:srgbClr val="D97706"/>
           </a:solidFill>
           <a:ln>
             <a:noFill/>
@@ -12255,7 +12255,7 @@
             </a:avLst>
           </a:prstGeom>
           <a:solidFill>
-            <a:srgbClr val="F0F4FF"/>
+            <a:srgbClr val="E0E7FF"/>
           </a:solidFill>
           <a:ln>
             <a:noFill/>
@@ -12282,7 +12282,7 @@
             <a:avLst/>
           </a:prstGeom>
           <a:solidFill>
-            <a:srgbClr val="1D4ED8"/>
+            <a:srgbClr val="2563EB"/>
           </a:solidFill>
           <a:ln>
             <a:noFill/>
@@ -12321,7 +12321,7 @@
             <a:r>
               <a:rPr lang="uz-UZ" sz="2000" b="1" i="0" dirty="0">
                 <a:solidFill>
-                  <a:srgbClr val="1D4ED8"/>
+                  <a:srgbClr val="2563EB"/>
                 </a:solidFill>
               </a:rPr>
               <a:t>SQL baza</a:t>
@@ -12356,7 +12356,7 @@
             <a:r>
               <a:rPr lang="uz-UZ" sz="1700" b="0" i="0" dirty="0">
                 <a:solidFill>
-                  <a:srgbClr val="1F2937"/>
+                  <a:srgbClr val="374151"/>
                 </a:solidFill>
               </a:rPr>
               <a:t>3 oylik monitoring ma'lumotlari</a:t>
@@ -12381,7 +12381,7 @@
             </a:avLst>
           </a:prstGeom>
           <a:solidFill>
-            <a:srgbClr val="1D4ED8"/>
+            <a:srgbClr val="2563EB"/>
           </a:solidFill>
           <a:ln>
             <a:noFill/>
@@ -12445,7 +12445,7 @@
             </a:avLst>
           </a:prstGeom>
           <a:solidFill>
-            <a:srgbClr val="F0F4FF"/>
+            <a:srgbClr val="E0E7FF"/>
           </a:solidFill>
           <a:ln>
             <a:noFill/>
@@ -12472,7 +12472,7 @@
             <a:avLst/>
           </a:prstGeom>
           <a:solidFill>
-            <a:srgbClr val="DC2626"/>
+            <a:srgbClr val="E11D48"/>
           </a:solidFill>
           <a:ln>
             <a:noFill/>
@@ -12511,7 +12511,7 @@
             <a:r>
               <a:rPr lang="uz-UZ" sz="2000" b="1" i="0" dirty="0">
                 <a:solidFill>
-                  <a:srgbClr val="DC2626"/>
+                  <a:srgbClr val="E11D48"/>
                 </a:solidFill>
               </a:rPr>
               <a:t>Xavfsizlik</a:t>
@@ -12546,7 +12546,7 @@
             <a:r>
               <a:rPr lang="uz-UZ" sz="1700" b="0" i="0" dirty="0">
                 <a:solidFill>
-                  <a:srgbClr val="1F2937"/>
+                  <a:srgbClr val="374151"/>
                 </a:solidFill>
               </a:rPr>
               <a:t>SHA-256 shifrlash joriy etish</a:t>
@@ -12571,7 +12571,7 @@
             </a:avLst>
           </a:prstGeom>
           <a:solidFill>
-            <a:srgbClr val="DC2626"/>
+            <a:srgbClr val="E11D48"/>
           </a:solidFill>
           <a:ln>
             <a:noFill/>
@@ -12635,7 +12635,7 @@
             </a:avLst>
           </a:prstGeom>
           <a:solidFill>
-            <a:srgbClr val="FFF8E1"/>
+            <a:srgbClr val="FEF9EC"/>
           </a:solidFill>
           <a:ln>
             <a:noFill/>
@@ -12662,7 +12662,7 @@
             <a:avLst/>
           </a:prstGeom>
           <a:solidFill>
-            <a:srgbClr val="B8860B"/>
+            <a:srgbClr val="D97706"/>
           </a:solidFill>
           <a:ln>
             <a:noFill/>
@@ -12701,7 +12701,7 @@
             <a:r>
               <a:rPr lang="uz-UZ" sz="1700" b="0" i="0" dirty="0">
                 <a:solidFill>
-                  <a:srgbClr val="B8860B"/>
+                  <a:srgbClr val="D97706"/>
                 </a:solidFill>
               </a:rPr>
               <a:t>Multithreading texnikasi: Skanerlash vaqti 12 daqiqadan 45 soniyaga tushirildi → 94% samaradorlik oshishi</a:t>
@@ -12784,7 +12784,7 @@
             <a:avLst/>
           </a:prstGeom>
           <a:solidFill>
-            <a:srgbClr val="FFFFFF"/>
+            <a:srgbClr val="F8F9FF"/>
           </a:solidFill>
           <a:ln>
             <a:noFill/>
@@ -12805,7 +12805,7 @@
         <p:spPr>
           <a:xfrm>
             <a:off x="0" y="0"/>
-            <a:ext cx="12193200" cy="355600"/>
+            <a:ext cx="12193200" cy="406400"/>
           </a:xfrm>
           <a:prstGeom prst="rect">
             <a:avLst/>
@@ -12831,8 +12831,8 @@
         </p:nvSpPr>
         <p:spPr>
           <a:xfrm>
-            <a:off x="0" y="6502400"/>
-            <a:ext cx="12193200" cy="355600"/>
+            <a:off x="0" y="6451600"/>
+            <a:ext cx="12193200" cy="406400"/>
           </a:xfrm>
           <a:prstGeom prst="rect">
             <a:avLst/>
@@ -12858,8 +12858,8 @@
         </p:nvSpPr>
         <p:spPr>
           <a:xfrm>
-            <a:off x="0" y="355600"/>
-            <a:ext cx="127000" cy="6146800"/>
+            <a:off x="0" y="406400"/>
+            <a:ext cx="152400" cy="6045200"/>
           </a:xfrm>
           <a:prstGeom prst="rect">
             <a:avLst/>
@@ -12995,7 +12995,7 @@
             <a:r>
               <a:rPr lang="uz-UZ" sz="2200" b="1" i="0" dirty="0">
                 <a:solidFill>
-                  <a:srgbClr val="111827"/>
+                  <a:srgbClr val="1E1B4B"/>
                 </a:solidFill>
               </a:rPr>
               <a:t>AT loyihasi davomida xatti-harakatlarni yaxshilashni tavsiya etish</a:t>
@@ -13047,7 +13047,7 @@
             </a:avLst>
           </a:prstGeom>
           <a:solidFill>
-            <a:srgbClr val="F0F4FF"/>
+            <a:srgbClr val="E0E7FF"/>
           </a:solidFill>
           <a:ln>
             <a:noFill/>
@@ -13074,7 +13074,7 @@
             <a:avLst/>
           </a:prstGeom>
           <a:solidFill>
-            <a:srgbClr val="B8860B"/>
+            <a:srgbClr val="D97706"/>
           </a:solidFill>
           <a:ln>
             <a:noFill/>
@@ -13113,7 +13113,7 @@
             <a:r>
               <a:rPr lang="uz-UZ" sz="1900" b="1" i="0" dirty="0">
                 <a:solidFill>
-                  <a:srgbClr val="B8860B"/>
+                  <a:srgbClr val="D97706"/>
                 </a:solidFill>
               </a:rPr>
               <a:t>📋 Sprint Planning</a:t>
@@ -13148,7 +13148,7 @@
             <a:r>
               <a:rPr lang="uz-UZ" sz="1650" b="0" i="0" dirty="0">
                 <a:solidFill>
-                  <a:srgbClr val="1F2937"/>
+                  <a:srgbClr val="374151"/>
                 </a:solidFill>
               </a:rPr>
               <a:t>Har sprint boshida 2 soatlik talablar sessiyasi — kechikishni 70% kamaytiradi</a:t>
@@ -13173,7 +13173,7 @@
             </a:avLst>
           </a:prstGeom>
           <a:solidFill>
-            <a:srgbClr val="F0F4FF"/>
+            <a:srgbClr val="E0E7FF"/>
           </a:solidFill>
           <a:ln>
             <a:noFill/>
@@ -13200,7 +13200,7 @@
             <a:avLst/>
           </a:prstGeom>
           <a:solidFill>
-            <a:srgbClr val="1D4ED8"/>
+            <a:srgbClr val="2563EB"/>
           </a:solidFill>
           <a:ln>
             <a:noFill/>
@@ -13239,7 +13239,7 @@
             <a:r>
               <a:rPr lang="uz-UZ" sz="1900" b="1" i="0" dirty="0">
                 <a:solidFill>
-                  <a:srgbClr val="1D4ED8"/>
+                  <a:srgbClr val="2563EB"/>
                 </a:solidFill>
               </a:rPr>
               <a:t>🧪 CI/CD Pipeline</a:t>
@@ -13274,7 +13274,7 @@
             <a:r>
               <a:rPr lang="uz-UZ" sz="1650" b="0" i="0" dirty="0">
                 <a:solidFill>
-                  <a:srgbClr val="1F2937"/>
+                  <a:srgbClr val="374151"/>
                 </a:solidFill>
               </a:rPr>
               <a:t>GitHub Actions bilan avtomatik test va deploy — nosoz kod oldini oladi</a:t>
@@ -13299,7 +13299,7 @@
             </a:avLst>
           </a:prstGeom>
           <a:solidFill>
-            <a:srgbClr val="F0F4FF"/>
+            <a:srgbClr val="E0E7FF"/>
           </a:solidFill>
           <a:ln>
             <a:noFill/>
@@ -13400,7 +13400,7 @@
             <a:r>
               <a:rPr lang="uz-UZ" sz="1650" b="0" i="0" dirty="0">
                 <a:solidFill>
-                  <a:srgbClr val="1F2937"/>
+                  <a:srgbClr val="374151"/>
                 </a:solidFill>
               </a:rPr>
               <a:t>Har kecha 02:00 da bulutga backup — ma'lumot yo'qolish xavfi nol</a:t>
@@ -13425,7 +13425,7 @@
             </a:avLst>
           </a:prstGeom>
           <a:solidFill>
-            <a:srgbClr val="F0F4FF"/>
+            <a:srgbClr val="E0E7FF"/>
           </a:solidFill>
           <a:ln>
             <a:noFill/>
@@ -13452,7 +13452,7 @@
             <a:avLst/>
           </a:prstGeom>
           <a:solidFill>
-            <a:srgbClr val="DC2626"/>
+            <a:srgbClr val="E11D48"/>
           </a:solidFill>
           <a:ln>
             <a:noFill/>
@@ -13491,7 +13491,7 @@
             <a:r>
               <a:rPr lang="uz-UZ" sz="1900" b="1" i="0" dirty="0">
                 <a:solidFill>
-                  <a:srgbClr val="DC2626"/>
+                  <a:srgbClr val="E11D48"/>
                 </a:solidFill>
               </a:rPr>
               <a:t>📚 Lunch &amp; Learn</a:t>
@@ -13526,7 +13526,7 @@
             <a:r>
               <a:rPr lang="uz-UZ" sz="1650" b="0" i="0" dirty="0">
                 <a:solidFill>
-                  <a:srgbClr val="1F2937"/>
+                  <a:srgbClr val="374151"/>
                 </a:solidFill>
               </a:rPr>
               <a:t>Har 2 haftada texnik bilim almashish — jamoa darajasini oshiradi</a:t>
@@ -13551,7 +13551,7 @@
             </a:avLst>
           </a:prstGeom>
           <a:solidFill>
-            <a:srgbClr val="F0F4FF"/>
+            <a:srgbClr val="E0E7FF"/>
           </a:solidFill>
           <a:ln>
             <a:noFill/>
@@ -13652,7 +13652,7 @@
             <a:r>
               <a:rPr lang="uz-UZ" sz="1650" b="0" i="0" dirty="0">
                 <a:solidFill>
-                  <a:srgbClr val="1F2937"/>
+                  <a:srgbClr val="374151"/>
                 </a:solidFill>
               </a:rPr>
               <a:t>Confluence/Notion da real vaqt yangilanish — bus factor kamayadi</a:t>
@@ -13735,7 +13735,7 @@
             <a:avLst/>
           </a:prstGeom>
           <a:solidFill>
-            <a:srgbClr val="FFFFFF"/>
+            <a:srgbClr val="F8F9FF"/>
           </a:solidFill>
           <a:ln>
             <a:noFill/>
@@ -13756,13 +13756,13 @@
         <p:spPr>
           <a:xfrm>
             <a:off x="0" y="0"/>
-            <a:ext cx="12193200" cy="355600"/>
-          </a:xfrm>
-          <a:prstGeom prst="rect">
-            <a:avLst/>
-          </a:prstGeom>
-          <a:solidFill>
-            <a:srgbClr val="1D4ED8"/>
+            <a:ext cx="12193200" cy="406400"/>
+          </a:xfrm>
+          <a:prstGeom prst="rect">
+            <a:avLst/>
+          </a:prstGeom>
+          <a:solidFill>
+            <a:srgbClr val="2563EB"/>
           </a:solidFill>
           <a:ln>
             <a:noFill/>
@@ -13782,14 +13782,14 @@
         </p:nvSpPr>
         <p:spPr>
           <a:xfrm>
-            <a:off x="0" y="6502400"/>
-            <a:ext cx="12193200" cy="355600"/>
-          </a:xfrm>
-          <a:prstGeom prst="rect">
-            <a:avLst/>
-          </a:prstGeom>
-          <a:solidFill>
-            <a:srgbClr val="1D4ED8"/>
+            <a:off x="0" y="6451600"/>
+            <a:ext cx="12193200" cy="406400"/>
+          </a:xfrm>
+          <a:prstGeom prst="rect">
+            <a:avLst/>
+          </a:prstGeom>
+          <a:solidFill>
+            <a:srgbClr val="2563EB"/>
           </a:solidFill>
           <a:ln>
             <a:noFill/>
@@ -13809,14 +13809,14 @@
         </p:nvSpPr>
         <p:spPr>
           <a:xfrm>
-            <a:off x="0" y="355600"/>
-            <a:ext cx="127000" cy="6146800"/>
-          </a:xfrm>
-          <a:prstGeom prst="rect">
-            <a:avLst/>
-          </a:prstGeom>
-          <a:solidFill>
-            <a:srgbClr val="1D4ED8"/>
+            <a:off x="0" y="406400"/>
+            <a:ext cx="152400" cy="6045200"/>
+          </a:xfrm>
+          <a:prstGeom prst="rect">
+            <a:avLst/>
+          </a:prstGeom>
+          <a:solidFill>
+            <a:srgbClr val="2563EB"/>
           </a:solidFill>
           <a:ln>
             <a:noFill/>
@@ -13843,7 +13843,7 @@
             <a:avLst/>
           </a:prstGeom>
           <a:solidFill>
-            <a:srgbClr val="1D4ED8"/>
+            <a:srgbClr val="2563EB"/>
           </a:solidFill>
           <a:ln>
             <a:noFill/>
@@ -13872,7 +13872,7 @@
             </a:avLst>
           </a:prstGeom>
           <a:solidFill>
-            <a:srgbClr val="1D4ED8"/>
+            <a:srgbClr val="2563EB"/>
           </a:solidFill>
           <a:ln>
             <a:noFill/>
@@ -13946,7 +13946,7 @@
             <a:r>
               <a:rPr lang="uz-UZ" sz="2200" b="1" i="0" dirty="0">
                 <a:solidFill>
-                  <a:srgbClr val="111827"/>
+                  <a:srgbClr val="1E1B4B"/>
                 </a:solidFill>
               </a:rPr>
               <a:t>Loyiha boshqarish ko'nikmalaridan foydalanganligini tushuntirish</a:t>
@@ -13969,7 +13969,7 @@
             <a:avLst/>
           </a:prstGeom>
           <a:solidFill>
-            <a:srgbClr val="1D4ED8"/>
+            <a:srgbClr val="2563EB"/>
           </a:solidFill>
           <a:ln>
             <a:noFill/>
@@ -13996,7 +13996,7 @@
             <a:avLst/>
           </a:prstGeom>
           <a:solidFill>
-            <a:srgbClr val="2D3748"/>
+            <a:srgbClr val="CBD5E1"/>
           </a:solidFill>
           <a:ln>
             <a:noFill/>
@@ -14025,7 +14025,7 @@
             </a:avLst>
           </a:prstGeom>
           <a:solidFill>
-            <a:srgbClr val="F0F4FF"/>
+            <a:srgbClr val="E0E7FF"/>
           </a:solidFill>
           <a:ln>
             <a:noFill/>
@@ -14052,7 +14052,7 @@
             <a:avLst/>
           </a:prstGeom>
           <a:solidFill>
-            <a:srgbClr val="B8860B"/>
+            <a:srgbClr val="D97706"/>
           </a:solidFill>
           <a:ln>
             <a:noFill/>
@@ -14091,7 +14091,7 @@
             <a:r>
               <a:rPr lang="uz-UZ" sz="1600" b="1" i="0" dirty="0">
                 <a:solidFill>
-                  <a:srgbClr val="B8860B"/>
+                  <a:srgbClr val="D97706"/>
                 </a:solidFill>
               </a:rPr>
               <a:t>1-hafta</a:t>
@@ -14126,7 +14126,7 @@
             <a:r>
               <a:rPr lang="uz-UZ" sz="2000" b="1" i="0" dirty="0">
                 <a:solidFill>
-                  <a:srgbClr val="111827"/>
+                  <a:srgbClr val="1E1B4B"/>
                 </a:solidFill>
               </a:rPr>
               <a:t>Tahlil</a:t>
@@ -14161,7 +14161,7 @@
             <a:r>
               <a:rPr lang="uz-UZ" sz="1500" b="0" i="0" dirty="0">
                 <a:solidFill>
-                  <a:srgbClr val="1F2937"/>
+                  <a:srgbClr val="374151"/>
                 </a:solidFill>
               </a:rPr>
               <a:t>TOR hujjati tayyorlandi</a:t>
@@ -14186,7 +14186,7 @@
             </a:avLst>
           </a:prstGeom>
           <a:solidFill>
-            <a:srgbClr val="B8860B"/>
+            <a:srgbClr val="D97706"/>
           </a:solidFill>
           <a:ln>
             <a:noFill/>
@@ -14215,7 +14215,7 @@
             </a:avLst>
           </a:prstGeom>
           <a:solidFill>
-            <a:srgbClr val="F0F4FF"/>
+            <a:srgbClr val="E0E7FF"/>
           </a:solidFill>
           <a:ln>
             <a:noFill/>
@@ -14242,7 +14242,7 @@
             <a:avLst/>
           </a:prstGeom>
           <a:solidFill>
-            <a:srgbClr val="1D4ED8"/>
+            <a:srgbClr val="2563EB"/>
           </a:solidFill>
           <a:ln>
             <a:noFill/>
@@ -14281,7 +14281,7 @@
             <a:r>
               <a:rPr lang="uz-UZ" sz="1600" b="1" i="0" dirty="0">
                 <a:solidFill>
-                  <a:srgbClr val="1D4ED8"/>
+                  <a:srgbClr val="2563EB"/>
                 </a:solidFill>
               </a:rPr>
               <a:t>3-5 kun</a:t>
@@ -14316,7 +14316,7 @@
             <a:r>
               <a:rPr lang="uz-UZ" sz="2000" b="1" i="0" dirty="0">
                 <a:solidFill>
-                  <a:srgbClr val="111827"/>
+                  <a:srgbClr val="1E1B4B"/>
                 </a:solidFill>
               </a:rPr>
               <a:t>Arxitektura</a:t>
@@ -14351,7 +14351,7 @@
             <a:r>
               <a:rPr lang="uz-UZ" sz="1500" b="0" i="0" dirty="0">
                 <a:solidFill>
-                  <a:srgbClr val="1F2937"/>
+                  <a:srgbClr val="374151"/>
                 </a:solidFill>
               </a:rPr>
               <a:t>UML diagrammalar yaratildi</a:t>
@@ -14376,7 +14376,7 @@
             </a:avLst>
           </a:prstGeom>
           <a:solidFill>
-            <a:srgbClr val="1D4ED8"/>
+            <a:srgbClr val="2563EB"/>
           </a:solidFill>
           <a:ln>
             <a:noFill/>
@@ -14405,7 +14405,7 @@
             </a:avLst>
           </a:prstGeom>
           <a:solidFill>
-            <a:srgbClr val="F0F4FF"/>
+            <a:srgbClr val="E0E7FF"/>
           </a:solidFill>
           <a:ln>
             <a:noFill/>
@@ -14432,7 +14432,7 @@
             <a:avLst/>
           </a:prstGeom>
           <a:solidFill>
-            <a:srgbClr val="15803D"/>
+            <a:srgbClr val="059669"/>
           </a:solidFill>
           <a:ln>
             <a:noFill/>
@@ -14471,7 +14471,7 @@
             <a:r>
               <a:rPr lang="uz-UZ" sz="1600" b="1" i="0" dirty="0">
                 <a:solidFill>
-                  <a:srgbClr val="15803D"/>
+                  <a:srgbClr val="059669"/>
                 </a:solidFill>
               </a:rPr>
               <a:t>3-hafta</a:t>
@@ -14506,7 +14506,7 @@
             <a:r>
               <a:rPr lang="uz-UZ" sz="2000" b="1" i="0" dirty="0">
                 <a:solidFill>
-                  <a:srgbClr val="111827"/>
+                  <a:srgbClr val="1E1B4B"/>
                 </a:solidFill>
               </a:rPr>
               <a:t>Backend</a:t>
@@ -14541,7 +14541,7 @@
             <a:r>
               <a:rPr lang="uz-UZ" sz="1500" b="0" i="0" dirty="0">
                 <a:solidFill>
-                  <a:srgbClr val="1F2937"/>
+                  <a:srgbClr val="374151"/>
                 </a:solidFill>
               </a:rPr>
               <a:t>Monitor + DB modullari</a:t>
@@ -14566,7 +14566,7 @@
             </a:avLst>
           </a:prstGeom>
           <a:solidFill>
-            <a:srgbClr val="15803D"/>
+            <a:srgbClr val="059669"/>
           </a:solidFill>
           <a:ln>
             <a:noFill/>
@@ -14595,7 +14595,7 @@
             </a:avLst>
           </a:prstGeom>
           <a:solidFill>
-            <a:srgbClr val="F0F4FF"/>
+            <a:srgbClr val="E0E7FF"/>
           </a:solidFill>
           <a:ln>
             <a:noFill/>
@@ -14696,7 +14696,7 @@
             <a:r>
               <a:rPr lang="uz-UZ" sz="2000" b="1" i="0" dirty="0">
                 <a:solidFill>
-                  <a:srgbClr val="111827"/>
+                  <a:srgbClr val="1E1B4B"/>
                 </a:solidFill>
               </a:rPr>
               <a:t>GUI</a:t>
@@ -14731,7 +14731,7 @@
             <a:r>
               <a:rPr lang="uz-UZ" sz="1500" b="0" i="0" dirty="0">
                 <a:solidFill>
-                  <a:srgbClr val="1F2937"/>
+                  <a:srgbClr val="374151"/>
                 </a:solidFill>
               </a:rPr>
               <a:t>Tkinter interfeysi</a:t>
@@ -14785,7 +14785,7 @@
             </a:avLst>
           </a:prstGeom>
           <a:solidFill>
-            <a:srgbClr val="F0F4FF"/>
+            <a:srgbClr val="E0E7FF"/>
           </a:solidFill>
           <a:ln>
             <a:noFill/>
@@ -14886,7 +14886,7 @@
             <a:r>
               <a:rPr lang="uz-UZ" sz="2000" b="1" i="0" dirty="0">
                 <a:solidFill>
-                  <a:srgbClr val="111827"/>
+                  <a:srgbClr val="1E1B4B"/>
                 </a:solidFill>
               </a:rPr>
               <a:t>Test</a:t>
@@ -14921,7 +14921,7 @@
             <a:r>
               <a:rPr lang="uz-UZ" sz="1500" b="0" i="0" dirty="0">
                 <a:solidFill>
-                  <a:srgbClr val="1F2937"/>
+                  <a:srgbClr val="374151"/>
                 </a:solidFill>
               </a:rPr>
               <a:t>0 kritik xato</a:t>
@@ -14975,7 +14975,7 @@
             </a:avLst>
           </a:prstGeom>
           <a:solidFill>
-            <a:srgbClr val="F0F4FF"/>
+            <a:srgbClr val="E0E7FF"/>
           </a:solidFill>
           <a:ln>
             <a:noFill/>
@@ -15002,7 +15002,7 @@
             <a:avLst/>
           </a:prstGeom>
           <a:solidFill>
-            <a:srgbClr val="DC2626"/>
+            <a:srgbClr val="E11D48"/>
           </a:solidFill>
           <a:ln>
             <a:noFill/>
@@ -15041,7 +15041,7 @@
             <a:r>
               <a:rPr lang="uz-UZ" sz="1600" b="1" i="0" dirty="0">
                 <a:solidFill>
-                  <a:srgbClr val="DC2626"/>
+                  <a:srgbClr val="E11D48"/>
                 </a:solidFill>
               </a:rPr>
               <a:t>2-kun</a:t>
@@ -15076,7 +15076,7 @@
             <a:r>
               <a:rPr lang="uz-UZ" sz="2000" b="1" i="0" dirty="0">
                 <a:solidFill>
-                  <a:srgbClr val="111827"/>
+                  <a:srgbClr val="1E1B4B"/>
                 </a:solidFill>
               </a:rPr>
               <a:t>Deploy</a:t>
@@ -15111,7 +15111,7 @@
             <a:r>
               <a:rPr lang="uz-UZ" sz="1500" b="0" i="0" dirty="0">
                 <a:solidFill>
-                  <a:srgbClr val="1F2937"/>
+                  <a:srgbClr val="374151"/>
                 </a:solidFill>
               </a:rPr>
               <a:t>Ishlab chiqarishga chiqarildi</a:t>
@@ -15136,7 +15136,7 @@
             </a:avLst>
           </a:prstGeom>
           <a:solidFill>
-            <a:srgbClr val="DC2626"/>
+            <a:srgbClr val="E11D48"/>
           </a:solidFill>
           <a:ln>
             <a:noFill/>
@@ -15175,7 +15175,7 @@
             <a:r>
               <a:rPr lang="uz-UZ" sz="2000" b="1" i="0" dirty="0">
                 <a:solidFill>
-                  <a:srgbClr val="B8860B"/>
+                  <a:srgbClr val="D97706"/>
                 </a:solidFill>
               </a:rPr>
               <a:t>RISK BOSHQARUVI</a:t>
@@ -15200,7 +15200,7 @@
             </a:avLst>
           </a:prstGeom>
           <a:solidFill>
-            <a:srgbClr val="F0F4FF"/>
+            <a:srgbClr val="E0E7FF"/>
           </a:solidFill>
           <a:ln>
             <a:noFill/>
@@ -15227,7 +15227,7 @@
             <a:avLst/>
           </a:prstGeom>
           <a:solidFill>
-            <a:srgbClr val="B8860B"/>
+            <a:srgbClr val="D97706"/>
           </a:solidFill>
           <a:ln>
             <a:noFill/>
@@ -15266,7 +15266,7 @@
             <a:r>
               <a:rPr lang="uz-UZ" sz="1700" b="1" i="0" dirty="0">
                 <a:solidFill>
-                  <a:srgbClr val="111827"/>
+                  <a:srgbClr val="1E1B4B"/>
                 </a:solidFill>
               </a:rPr>
               <a:t>Ma'lumot yo'qolishi</a:t>
@@ -15291,7 +15291,7 @@
             </a:avLst>
           </a:prstGeom>
           <a:solidFill>
-            <a:srgbClr val="B8860B"/>
+            <a:srgbClr val="D97706"/>
           </a:solidFill>
           <a:ln>
             <a:noFill/>
@@ -15365,7 +15365,7 @@
             <a:r>
               <a:rPr lang="uz-UZ" sz="1700" b="0" i="0" dirty="0">
                 <a:solidFill>
-                  <a:srgbClr val="1F2937"/>
+                  <a:srgbClr val="374151"/>
                 </a:solidFill>
               </a:rPr>
               <a:t>Kunlik avtomatik backup</a:t>
@@ -15390,7 +15390,7 @@
             </a:avLst>
           </a:prstGeom>
           <a:solidFill>
-            <a:srgbClr val="F0F4FF"/>
+            <a:srgbClr val="E0E7FF"/>
           </a:solidFill>
           <a:ln>
             <a:noFill/>
@@ -15417,7 +15417,7 @@
             <a:avLst/>
           </a:prstGeom>
           <a:solidFill>
-            <a:srgbClr val="15803D"/>
+            <a:srgbClr val="059669"/>
           </a:solidFill>
           <a:ln>
             <a:noFill/>
@@ -15456,7 +15456,7 @@
             <a:r>
               <a:rPr lang="uz-UZ" sz="1700" b="1" i="0" dirty="0">
                 <a:solidFill>
-                  <a:srgbClr val="111827"/>
+                  <a:srgbClr val="1E1B4B"/>
                 </a:solidFill>
               </a:rPr>
               <a:t>Server nosozligi</a:t>
@@ -15481,7 +15481,7 @@
             </a:avLst>
           </a:prstGeom>
           <a:solidFill>
-            <a:srgbClr val="15803D"/>
+            <a:srgbClr val="059669"/>
           </a:solidFill>
           <a:ln>
             <a:noFill/>
@@ -15555,7 +15555,7 @@
             <a:r>
               <a:rPr lang="uz-UZ" sz="1700" b="0" i="0" dirty="0">
                 <a:solidFill>
-                  <a:srgbClr val="1F2937"/>
+                  <a:srgbClr val="374151"/>
                 </a:solidFill>
               </a:rPr>
               <a:t>Redundant server konfiguratsiya</a:t>
@@ -15580,7 +15580,7 @@
             </a:avLst>
           </a:prstGeom>
           <a:solidFill>
-            <a:srgbClr val="F0F4FF"/>
+            <a:srgbClr val="E0E7FF"/>
           </a:solidFill>
           <a:ln>
             <a:noFill/>
@@ -15607,7 +15607,7 @@
             <a:avLst/>
           </a:prstGeom>
           <a:solidFill>
-            <a:srgbClr val="B8860B"/>
+            <a:srgbClr val="D97706"/>
           </a:solidFill>
           <a:ln>
             <a:noFill/>
@@ -15646,7 +15646,7 @@
             <a:r>
               <a:rPr lang="uz-UZ" sz="1700" b="1" i="0" dirty="0">
                 <a:solidFill>
-                  <a:srgbClr val="111827"/>
+                  <a:srgbClr val="1E1B4B"/>
                 </a:solidFill>
               </a:rPr>
               <a:t>Xavfsizlik buzilishi</a:t>
@@ -15671,7 +15671,7 @@
             </a:avLst>
           </a:prstGeom>
           <a:solidFill>
-            <a:srgbClr val="B8860B"/>
+            <a:srgbClr val="D97706"/>
           </a:solidFill>
           <a:ln>
             <a:noFill/>
@@ -15745,7 +15745,7 @@
             <a:r>
               <a:rPr lang="uz-UZ" sz="1700" b="0" i="0" dirty="0">
                 <a:solidFill>
-                  <a:srgbClr val="1F2937"/>
+                  <a:srgbClr val="374151"/>
                 </a:solidFill>
               </a:rPr>
               <a:t>Penetration test va shifrlash</a:t>
@@ -15828,7 +15828,7 @@
             <a:avLst/>
           </a:prstGeom>
           <a:solidFill>
-            <a:srgbClr val="FFFFFF"/>
+            <a:srgbClr val="F8F9FF"/>
           </a:solidFill>
           <a:ln>
             <a:noFill/>
@@ -15849,13 +15849,13 @@
         <p:spPr>
           <a:xfrm>
             <a:off x="0" y="0"/>
-            <a:ext cx="12193200" cy="355600"/>
-          </a:xfrm>
-          <a:prstGeom prst="rect">
-            <a:avLst/>
-          </a:prstGeom>
-          <a:solidFill>
-            <a:srgbClr val="DC2626"/>
+            <a:ext cx="12193200" cy="406400"/>
+          </a:xfrm>
+          <a:prstGeom prst="rect">
+            <a:avLst/>
+          </a:prstGeom>
+          <a:solidFill>
+            <a:srgbClr val="E11D48"/>
           </a:solidFill>
           <a:ln>
             <a:noFill/>
@@ -15875,14 +15875,14 @@
         </p:nvSpPr>
         <p:spPr>
           <a:xfrm>
-            <a:off x="0" y="6502400"/>
-            <a:ext cx="12193200" cy="355600"/>
-          </a:xfrm>
-          <a:prstGeom prst="rect">
-            <a:avLst/>
-          </a:prstGeom>
-          <a:solidFill>
-            <a:srgbClr val="DC2626"/>
+            <a:off x="0" y="6451600"/>
+            <a:ext cx="12193200" cy="406400"/>
+          </a:xfrm>
+          <a:prstGeom prst="rect">
+            <a:avLst/>
+          </a:prstGeom>
+          <a:solidFill>
+            <a:srgbClr val="E11D48"/>
           </a:solidFill>
           <a:ln>
             <a:noFill/>
@@ -15902,14 +15902,14 @@
         </p:nvSpPr>
         <p:spPr>
           <a:xfrm>
-            <a:off x="0" y="355600"/>
-            <a:ext cx="127000" cy="6146800"/>
-          </a:xfrm>
-          <a:prstGeom prst="rect">
-            <a:avLst/>
-          </a:prstGeom>
-          <a:solidFill>
-            <a:srgbClr val="DC2626"/>
+            <a:off x="0" y="406400"/>
+            <a:ext cx="152400" cy="6045200"/>
+          </a:xfrm>
+          <a:prstGeom prst="rect">
+            <a:avLst/>
+          </a:prstGeom>
+          <a:solidFill>
+            <a:srgbClr val="E11D48"/>
           </a:solidFill>
           <a:ln>
             <a:noFill/>
@@ -15936,7 +15936,7 @@
             <a:avLst/>
           </a:prstGeom>
           <a:solidFill>
-            <a:srgbClr val="DC2626"/>
+            <a:srgbClr val="E11D48"/>
           </a:solidFill>
           <a:ln>
             <a:noFill/>
@@ -15965,7 +15965,7 @@
             </a:avLst>
           </a:prstGeom>
           <a:solidFill>
-            <a:srgbClr val="DC2626"/>
+            <a:srgbClr val="E11D48"/>
           </a:solidFill>
           <a:ln>
             <a:noFill/>
@@ -16039,7 +16039,7 @@
             <a:r>
               <a:rPr lang="uz-UZ" sz="2200" b="1" i="0" dirty="0">
                 <a:solidFill>
-                  <a:srgbClr val="111827"/>
+                  <a:srgbClr val="1E1B4B"/>
                 </a:solidFill>
               </a:rPr>
               <a:t>AT loyihasini boshqarishda tegishli xatti-harakatlarni qo'llash</a:t>
@@ -16062,7 +16062,7 @@
             <a:avLst/>
           </a:prstGeom>
           <a:solidFill>
-            <a:srgbClr val="DC2626"/>
+            <a:srgbClr val="E11D48"/>
           </a:solidFill>
           <a:ln>
             <a:noFill/>
@@ -16091,7 +16091,7 @@
             </a:avLst>
           </a:prstGeom>
           <a:solidFill>
-            <a:srgbClr val="F0F4FF"/>
+            <a:srgbClr val="E0E7FF"/>
           </a:solidFill>
           <a:ln>
             <a:noFill/>
@@ -16118,7 +16118,7 @@
             <a:avLst/>
           </a:prstGeom>
           <a:solidFill>
-            <a:srgbClr val="DC2626"/>
+            <a:srgbClr val="E11D48"/>
           </a:solidFill>
           <a:ln>
             <a:noFill/>
@@ -16157,7 +16157,7 @@
             <a:r>
               <a:rPr lang="uz-UZ" sz="2000" b="1" i="0" dirty="0">
                 <a:solidFill>
-                  <a:srgbClr val="DC2626"/>
+                  <a:srgbClr val="E11D48"/>
                 </a:solidFill>
               </a:rPr>
               <a:t>🔐 Ma'lumotlar Maxfiyligi</a:t>
@@ -16192,7 +16192,7 @@
             <a:r>
               <a:rPr lang="uz-UZ" sz="1700" b="0" i="0" dirty="0">
                 <a:solidFill>
-                  <a:srgbClr val="1F2937"/>
+                  <a:srgbClr val="374151"/>
                 </a:solidFill>
               </a:rPr>
               <a:t>Monitoring ma'lumotlari faqat tizim ma'muri ko'radi. Har bir foydalanuvchi Privacy Policy bilan tanishtirildi.</a:t>
@@ -16217,7 +16217,7 @@
             </a:avLst>
           </a:prstGeom>
           <a:solidFill>
-            <a:srgbClr val="F0F4FF"/>
+            <a:srgbClr val="E0E7FF"/>
           </a:solidFill>
           <a:ln>
             <a:noFill/>
@@ -16244,7 +16244,7 @@
             <a:avLst/>
           </a:prstGeom>
           <a:solidFill>
-            <a:srgbClr val="B8860B"/>
+            <a:srgbClr val="D97706"/>
           </a:solidFill>
           <a:ln>
             <a:noFill/>
@@ -16283,7 +16283,7 @@
             <a:r>
               <a:rPr lang="uz-UZ" sz="2000" b="1" i="0" dirty="0">
                 <a:solidFill>
-                  <a:srgbClr val="B8860B"/>
+                  <a:srgbClr val="D97706"/>
                 </a:solidFill>
               </a:rPr>
               <a:t>🤝 Kasbiy Munosabatlar</a:t>
@@ -16318,7 +16318,7 @@
             <a:r>
               <a:rPr lang="uz-UZ" sz="1700" b="0" i="0" dirty="0">
                 <a:solidFill>
-                  <a:srgbClr val="1F2937"/>
+                  <a:srgbClr val="374151"/>
                 </a:solidFill>
               </a:rPr>
               <a:t>Yangi hamkasblarga mentorliq qildim. Jamoa ichida ishonch muhiti shakllantirildi.</a:t>
@@ -16343,7 +16343,7 @@
             </a:avLst>
           </a:prstGeom>
           <a:solidFill>
-            <a:srgbClr val="F0F4FF"/>
+            <a:srgbClr val="E0E7FF"/>
           </a:solidFill>
           <a:ln>
             <a:noFill/>
@@ -16370,7 +16370,7 @@
             <a:avLst/>
           </a:prstGeom>
           <a:solidFill>
-            <a:srgbClr val="1D4ED8"/>
+            <a:srgbClr val="2563EB"/>
           </a:solidFill>
           <a:ln>
             <a:noFill/>
@@ -16409,7 +16409,7 @@
             <a:r>
               <a:rPr lang="uz-UZ" sz="2000" b="1" i="0" dirty="0">
                 <a:solidFill>
-                  <a:srgbClr val="1D4ED8"/>
+                  <a:srgbClr val="2563EB"/>
                 </a:solidFill>
               </a:rPr>
               <a:t>📚 Doimiy O'rganish</a:t>
@@ -16444,7 +16444,7 @@
             <a:r>
               <a:rPr lang="uz-UZ" sz="1700" b="0" i="0" dirty="0">
                 <a:solidFill>
-                  <a:srgbClr val="1F2937"/>
+                  <a:srgbClr val="374151"/>
                 </a:solidFill>
               </a:rPr>
               <a:t>Docker, Grafana, REST API — loyiha davomida mustaqil o'rganildi va amaliyotda qo'llanildi.</a:t>
@@ -16469,7 +16469,7 @@
             </a:avLst>
           </a:prstGeom>
           <a:solidFill>
-            <a:srgbClr val="F0F4FF"/>
+            <a:srgbClr val="E0E7FF"/>
           </a:solidFill>
           <a:ln>
             <a:noFill/>
@@ -16496,7 +16496,7 @@
             <a:avLst/>
           </a:prstGeom>
           <a:solidFill>
-            <a:srgbClr val="15803D"/>
+            <a:srgbClr val="059669"/>
           </a:solidFill>
           <a:ln>
             <a:noFill/>
@@ -16535,7 +16535,7 @@
             <a:r>
               <a:rPr lang="uz-UZ" sz="2000" b="1" i="0" dirty="0">
                 <a:solidFill>
-                  <a:srgbClr val="15803D"/>
+                  <a:srgbClr val="059669"/>
                 </a:solidFill>
               </a:rPr>
               <a:t>⚖️ Litsenziya va Etika</a:t>
@@ -16570,7 +16570,7 @@
             <a:r>
               <a:rPr lang="uz-UZ" sz="1700" b="0" i="0" dirty="0">
                 <a:solidFill>
-                  <a:srgbClr val="1F2937"/>
+                  <a:srgbClr val="374151"/>
                 </a:solidFill>
               </a:rPr>
               <a:t>Barcha open-source kutubxonalar litsenziyalari tekshirildi. Intellektual mulk qoidalari to'liq bajarildi.</a:t>
@@ -16626,37 +16626,37 @@
   <a:themeElements>
     <a:clrScheme name="BTEC">
       <a:dk1>
-        <a:srgbClr val="111827"/>
+        <a:srgbClr val="1E1B4B"/>
       </a:dk1>
       <a:lt1>
-        <a:srgbClr val="FFFFFF"/>
+        <a:srgbClr val="F8F9FF"/>
       </a:lt1>
       <a:dk2>
-        <a:srgbClr val="1F2937"/>
+        <a:srgbClr val="374151"/>
       </a:dk2>
       <a:lt2>
-        <a:srgbClr val="F3F4F6"/>
+        <a:srgbClr val="EEF2FF"/>
       </a:lt2>
       <a:accent1>
-        <a:srgbClr val="B8860B"/>
+        <a:srgbClr val="D97706"/>
       </a:accent1>
       <a:accent2>
-        <a:srgbClr val="1D4ED8"/>
+        <a:srgbClr val="2563EB"/>
       </a:accent2>
       <a:accent3>
-        <a:srgbClr val="DC2626"/>
+        <a:srgbClr val="E11D48"/>
       </a:accent3>
       <a:accent4>
-        <a:srgbClr val="15803D"/>
+        <a:srgbClr val="059669"/>
       </a:accent4>
       <a:accent5>
         <a:srgbClr val="7C3AED"/>
       </a:accent5>
       <a:accent6>
-        <a:srgbClr val="0F766E"/>
+        <a:srgbClr val="0891B2"/>
       </a:accent6>
       <a:hlink>
-        <a:srgbClr val="1D4ED8"/>
+        <a:srgbClr val="2563EB"/>
       </a:hlink>
       <a:folHlink>
         <a:srgbClr val="6B7280"/>

</xml_diff>